<commit_message>
Redesign chart deck: dark stat cover, slide titles and takeaways, refined charts
Cover slide with kicker, title, and the four headline stats. Each chart
slide now carries a 26pt title and a one-line takeaway; in-chart titles
removed, plots enlarged, chart text scaled ~1.3x for projection, all value
axes unified to K-notation. Gray context bands and the capacity reference
line are now named in the legends; tissue series read 'Part 6665xx'; the
funnel drops its misreadable segment labels (stage totals live in the
category labels). The near-duplicate dashboard-hero chart is omitted from
the deck (still in the workbook).

Co-Authored-By: Claude Fable 5 <noreply@anthropic.com>
Claude-Session: https://claude.ai/code/session_014fnah7533XZizagq8i6MTs
</commit_message>
<xml_diff>
--- a/PVA second supplier initiative/Supplier_Capacity_Charts.pptx
+++ b/PVA second supplier initiative/Supplier_Capacity_Charts.pptx
@@ -116,62 +116,7 @@
 <chartSpace xmlns:a="http://schemas.openxmlformats.org/drawingml/2006/main" xmlns="http://schemas.openxmlformats.org/drawingml/2006/chart">
   <roundedCorners val="0"/>
   <chart>
-    <title>
-      <tx>
-        <rich>
-          <a:bodyPr/>
-          <a:p>
-            <a:pPr>
-              <a:defRPr sz="1200" b="1" i="0">
-                <a:solidFill>
-                  <a:srgbClr val="0B0B0B"/>
-                </a:solidFill>
-                <a:latin typeface="Aptos Narrow"/>
-              </a:defRPr>
-            </a:pPr>
-            <a:r>
-              <a:rPr sz="1200" b="1" i="0">
-                <a:solidFill>
-                  <a:srgbClr val="0B0B0B"/>
-                </a:solidFill>
-                <a:latin typeface="Aptos Narrow"/>
-              </a:rPr>
-              <a:t>Net supply at spec yield vs demand, Q4'26-Q4'27</a:t>
-            </a:r>
-          </a:p>
-          <a:p>
-            <a:pPr>
-              <a:defRPr sz="900" b="0" i="0">
-                <a:solidFill>
-                  <a:srgbClr val="7F7F7F"/>
-                </a:solidFill>
-                <a:latin typeface="Aptos Narrow"/>
-              </a:defRPr>
-            </a:pPr>
-            <a:r>
-              <a:rPr sz="900" b="0" i="0">
-                <a:solidFill>
-                  <a:srgbClr val="7F7F7F"/>
-                </a:solidFill>
-                <a:latin typeface="Aptos Narrow"/>
-              </a:rPr>
-              <a:t>Pigs per quarter. Spec-yield supply covers peak demand ~3.8x; gray band = gross kill (42.0K).</a:t>
-            </a:r>
-          </a:p>
-        </rich>
-      </tx>
-      <layout>
-        <manualLayout>
-          <xMode val="edge"/>
-          <yMode val="edge"/>
-          <wMode val="factor"/>
-          <hMode val="factor"/>
-          <x val="0.005"/>
-          <y val="0.02"/>
-        </manualLayout>
-      </layout>
-      <overlay val="0"/>
-    </title>
+    <autoTitleDeleted val="1"/>
     <plotArea>
       <layout>
         <manualLayout>
@@ -180,9 +125,9 @@
           <wMode val="factor"/>
           <hMode val="factor"/>
           <x val="0.055"/>
-          <y val="0.17"/>
+          <y val="0.05"/>
           <w val="0.93"/>
-          <h val="0.64"/>
+          <h val="0.78"/>
         </manualLayout>
       </layout>
       <barChart>
@@ -192,7 +137,7 @@
           <idx val="0"/>
           <order val="0"/>
           <tx>
-            <v>Gross kill (context)</v>
+            <v>Gross kill</v>
           </tx>
           <spPr>
             <a:solidFill>
@@ -301,7 +246,7 @@
               <a:bodyPr/>
               <a:p>
                 <a:pPr>
-                  <a:defRPr sz="900" b="1" i="0">
+                  <a:defRPr sz="1150" b="1" i="0">
                     <a:solidFill>
                       <a:srgbClr val="FFFFFF"/>
                     </a:solidFill>
@@ -311,7 +256,7 @@
                 <a:r>
                   <a:t/>
                 </a:r>
-                <a:endParaRPr sz="900" b="1" i="0">
+                <a:endParaRPr sz="1150" b="1" i="0">
                   <a:solidFill>
                     <a:srgbClr val="FFFFFF"/>
                   </a:solidFill>
@@ -493,7 +438,7 @@
               <a:bodyPr/>
               <a:p>
                 <a:pPr>
-                  <a:defRPr sz="900" b="1" i="0">
+                  <a:defRPr sz="1150" b="1" i="0">
                     <a:solidFill>
                       <a:srgbClr val="0B0B0B"/>
                     </a:solidFill>
@@ -503,7 +448,7 @@
                 <a:r>
                   <a:t/>
                 </a:r>
-                <a:endParaRPr sz="900" b="1" i="0">
+                <a:endParaRPr sz="1150" b="1" i="0">
                   <a:solidFill>
                     <a:srgbClr val="0B0B0B"/>
                   </a:solidFill>
@@ -589,7 +534,7 @@
               <a:bodyPr/>
               <a:p>
                 <a:pPr>
-                  <a:defRPr sz="900" b="1" i="0">
+                  <a:defRPr sz="1150" b="1" i="0">
                     <a:solidFill>
                       <a:srgbClr val="FFFFFF"/>
                     </a:solidFill>
@@ -599,7 +544,7 @@
                 <a:r>
                   <a:t/>
                 </a:r>
-                <a:endParaRPr sz="900" b="1" i="0">
+                <a:endParaRPr sz="1150" b="1" i="0">
                   <a:solidFill>
                     <a:srgbClr val="FFFFFF"/>
                   </a:solidFill>
@@ -666,7 +611,7 @@
               <a:bodyPr/>
               <a:p>
                 <a:pPr>
-                  <a:defRPr sz="900" b="1" i="0">
+                  <a:defRPr sz="1150" b="1" i="0">
                     <a:solidFill>
                       <a:srgbClr val="0B0B0B"/>
                     </a:solidFill>
@@ -676,7 +621,7 @@
                 <a:r>
                   <a:t/>
                 </a:r>
-                <a:endParaRPr sz="900" b="1" i="0">
+                <a:endParaRPr sz="1150" b="1" i="0">
                   <a:solidFill>
                     <a:srgbClr val="0B0B0B"/>
                   </a:solidFill>
@@ -749,7 +694,7 @@
               <a:bodyPr/>
               <a:p>
                 <a:pPr>
-                  <a:defRPr sz="900" b="1" i="0">
+                  <a:defRPr sz="1150" b="1" i="0">
                     <a:solidFill>
                       <a:srgbClr val="0B0B0B"/>
                     </a:solidFill>
@@ -759,7 +704,7 @@
                 <a:r>
                   <a:t/>
                 </a:r>
-                <a:endParaRPr sz="900" b="1" i="0">
+                <a:endParaRPr sz="1150" b="1" i="0">
                   <a:solidFill>
                     <a:srgbClr val="0B0B0B"/>
                   </a:solidFill>
@@ -827,7 +772,7 @@
           <a:bodyPr/>
           <a:p>
             <a:pPr>
-              <a:defRPr sz="900" b="0" i="0">
+              <a:defRPr sz="1150" b="0" i="0">
                 <a:solidFill>
                   <a:srgbClr val="595959"/>
                 </a:solidFill>
@@ -837,7 +782,7 @@
             <a:r>
               <a:t/>
             </a:r>
-            <a:endParaRPr sz="900" b="0" i="0">
+            <a:endParaRPr sz="1150" b="0" i="0">
               <a:solidFill>
                 <a:srgbClr val="595959"/>
               </a:solidFill>
@@ -881,7 +826,7 @@
           <a:bodyPr/>
           <a:p>
             <a:pPr>
-              <a:defRPr sz="900" b="0" i="0">
+              <a:defRPr sz="1150" b="0" i="0">
                 <a:solidFill>
                   <a:srgbClr val="595959"/>
                 </a:solidFill>
@@ -891,7 +836,7 @@
             <a:r>
               <a:t/>
             </a:r>
-            <a:endParaRPr sz="900" b="0" i="0">
+            <a:endParaRPr sz="1150" b="0" i="0">
               <a:solidFill>
                 <a:srgbClr val="595959"/>
               </a:solidFill>
@@ -919,10 +864,6 @@
     </plotArea>
     <legend>
       <legendPos val="b"/>
-      <legendEntry>
-        <idx val="0"/>
-        <delete val="1"/>
-      </legendEntry>
       <legendEntry>
         <idx val="6"/>
         <delete val="1"/>
@@ -948,7 +889,7 @@
         <a:bodyPr/>
         <a:p>
           <a:pPr>
-            <a:defRPr sz="900" b="0" i="0">
+            <a:defRPr sz="1150" b="0" i="0">
               <a:solidFill>
                 <a:srgbClr val="595959"/>
               </a:solidFill>
@@ -958,7 +899,7 @@
           <a:r>
             <a:t/>
           </a:r>
-          <a:endParaRPr sz="900" b="0" i="0">
+          <a:endParaRPr sz="1150" b="0" i="0">
             <a:solidFill>
               <a:srgbClr val="595959"/>
             </a:solidFill>
@@ -985,62 +926,7 @@
 <chartSpace xmlns:a="http://schemas.openxmlformats.org/drawingml/2006/main" xmlns="http://schemas.openxmlformats.org/drawingml/2006/chart">
   <roundedCorners val="0"/>
   <chart>
-    <title>
-      <tx>
-        <rich>
-          <a:bodyPr/>
-          <a:p>
-            <a:pPr>
-              <a:defRPr sz="1200" b="1" i="0">
-                <a:solidFill>
-                  <a:srgbClr val="0B0B0B"/>
-                </a:solidFill>
-                <a:latin typeface="Aptos Narrow"/>
-              </a:defRPr>
-            </a:pPr>
-            <a:r>
-              <a:rPr sz="1200" b="1" i="0">
-                <a:solidFill>
-                  <a:srgbClr val="0B0B0B"/>
-                </a:solidFill>
-                <a:latin typeface="Aptos Narrow"/>
-              </a:rPr>
-              <a:t>Net harvested supply vs demand, Q4'26-Q4'27</a:t>
-            </a:r>
-          </a:p>
-          <a:p>
-            <a:pPr>
-              <a:defRPr sz="900" b="0" i="0">
-                <a:solidFill>
-                  <a:srgbClr val="7F7F7F"/>
-                </a:solidFill>
-                <a:latin typeface="Aptos Narrow"/>
-              </a:defRPr>
-            </a:pPr>
-            <a:r>
-              <a:rPr sz="900" b="0" i="0">
-                <a:solidFill>
-                  <a:srgbClr val="7F7F7F"/>
-                </a:solidFill>
-                <a:latin typeface="Aptos Narrow"/>
-              </a:rPr>
-              <a:t>Pigs per quarter. Covers peak demand 2.6x; gray bands = gross kill (42.0K, light), net at spec (31.7K, mid).</a:t>
-            </a:r>
-          </a:p>
-        </rich>
-      </tx>
-      <layout>
-        <manualLayout>
-          <xMode val="edge"/>
-          <yMode val="edge"/>
-          <wMode val="factor"/>
-          <hMode val="factor"/>
-          <x val="0.005"/>
-          <y val="0.02"/>
-        </manualLayout>
-      </layout>
-      <overlay val="0"/>
-    </title>
+    <autoTitleDeleted val="1"/>
     <plotArea>
       <layout>
         <manualLayout>
@@ -1049,9 +935,9 @@
           <wMode val="factor"/>
           <hMode val="factor"/>
           <x val="0.055"/>
-          <y val="0.17"/>
+          <y val="0.05"/>
           <w val="0.93"/>
-          <h val="0.64"/>
+          <h val="0.78"/>
         </manualLayout>
       </layout>
       <barChart>
@@ -1061,7 +947,7 @@
           <idx val="0"/>
           <order val="0"/>
           <tx>
-            <v>Net at spec (context)</v>
+            <v>Net at spec yield</v>
           </tx>
           <spPr>
             <a:solidFill>
@@ -1124,7 +1010,7 @@
           <idx val="1"/>
           <order val="1"/>
           <tx>
-            <v>Spec-to-gross remainder (context)</v>
+            <v>Gross kill</v>
           </tx>
           <spPr>
             <a:solidFill>
@@ -1233,7 +1119,7 @@
               <a:bodyPr/>
               <a:p>
                 <a:pPr>
-                  <a:defRPr sz="900" b="1" i="0">
+                  <a:defRPr sz="1150" b="1" i="0">
                     <a:solidFill>
                       <a:srgbClr val="FFFFFF"/>
                     </a:solidFill>
@@ -1243,7 +1129,7 @@
                 <a:r>
                   <a:t/>
                 </a:r>
-                <a:endParaRPr sz="900" b="1" i="0">
+                <a:endParaRPr sz="1150" b="1" i="0">
                   <a:solidFill>
                     <a:srgbClr val="FFFFFF"/>
                   </a:solidFill>
@@ -1479,7 +1365,7 @@
               <a:bodyPr/>
               <a:p>
                 <a:pPr>
-                  <a:defRPr sz="900" b="1" i="0">
+                  <a:defRPr sz="1150" b="1" i="0">
                     <a:solidFill>
                       <a:srgbClr val="FFFFFF"/>
                     </a:solidFill>
@@ -1489,7 +1375,7 @@
                 <a:r>
                   <a:t/>
                 </a:r>
-                <a:endParaRPr sz="900" b="1" i="0">
+                <a:endParaRPr sz="1150" b="1" i="0">
                   <a:solidFill>
                     <a:srgbClr val="FFFFFF"/>
                   </a:solidFill>
@@ -1556,7 +1442,7 @@
               <a:bodyPr/>
               <a:p>
                 <a:pPr>
-                  <a:defRPr sz="900" b="1" i="0">
+                  <a:defRPr sz="1150" b="1" i="0">
                     <a:solidFill>
                       <a:srgbClr val="0B0B0B"/>
                     </a:solidFill>
@@ -1566,7 +1452,7 @@
                 <a:r>
                   <a:t/>
                 </a:r>
-                <a:endParaRPr sz="900" b="1" i="0">
+                <a:endParaRPr sz="1150" b="1" i="0">
                   <a:solidFill>
                     <a:srgbClr val="0B0B0B"/>
                   </a:solidFill>
@@ -1639,7 +1525,7 @@
               <a:bodyPr/>
               <a:p>
                 <a:pPr>
-                  <a:defRPr sz="900" b="1" i="0">
+                  <a:defRPr sz="1150" b="1" i="0">
                     <a:solidFill>
                       <a:srgbClr val="0B0B0B"/>
                     </a:solidFill>
@@ -1649,7 +1535,7 @@
                 <a:r>
                   <a:t/>
                 </a:r>
-                <a:endParaRPr sz="900" b="1" i="0">
+                <a:endParaRPr sz="1150" b="1" i="0">
                   <a:solidFill>
                     <a:srgbClr val="0B0B0B"/>
                   </a:solidFill>
@@ -1717,7 +1603,7 @@
           <a:bodyPr/>
           <a:p>
             <a:pPr>
-              <a:defRPr sz="900" b="0" i="0">
+              <a:defRPr sz="1150" b="0" i="0">
                 <a:solidFill>
                   <a:srgbClr val="595959"/>
                 </a:solidFill>
@@ -1727,7 +1613,7 @@
             <a:r>
               <a:t/>
             </a:r>
-            <a:endParaRPr sz="900" b="0" i="0">
+            <a:endParaRPr sz="1150" b="0" i="0">
               <a:solidFill>
                 <a:srgbClr val="595959"/>
               </a:solidFill>
@@ -1771,7 +1657,7 @@
           <a:bodyPr/>
           <a:p>
             <a:pPr>
-              <a:defRPr sz="900" b="0" i="0">
+              <a:defRPr sz="1150" b="0" i="0">
                 <a:solidFill>
                   <a:srgbClr val="595959"/>
                 </a:solidFill>
@@ -1781,7 +1667,7 @@
             <a:r>
               <a:t/>
             </a:r>
-            <a:endParaRPr sz="900" b="0" i="0">
+            <a:endParaRPr sz="1150" b="0" i="0">
               <a:solidFill>
                 <a:srgbClr val="595959"/>
               </a:solidFill>
@@ -1809,14 +1695,6 @@
     </plotArea>
     <legend>
       <legendPos val="b"/>
-      <legendEntry>
-        <idx val="0"/>
-        <delete val="1"/>
-      </legendEntry>
-      <legendEntry>
-        <idx val="1"/>
-        <delete val="1"/>
-      </legendEntry>
       <legendEntry>
         <idx val="7"/>
         <delete val="1"/>
@@ -1842,7 +1720,7 @@
         <a:bodyPr/>
         <a:p>
           <a:pPr>
-            <a:defRPr sz="900" b="0" i="0">
+            <a:defRPr sz="1150" b="0" i="0">
               <a:solidFill>
                 <a:srgbClr val="595959"/>
               </a:solidFill>
@@ -1852,7 +1730,7 @@
           <a:r>
             <a:t/>
           </a:r>
-          <a:endParaRPr sz="900" b="0" i="0">
+          <a:endParaRPr sz="1150" b="0" i="0">
             <a:solidFill>
               <a:srgbClr val="595959"/>
             </a:solidFill>
@@ -1879,81 +1757,7 @@
 <chartSpace xmlns:a="http://schemas.openxmlformats.org/drawingml/2006/main" xmlns="http://schemas.openxmlformats.org/drawingml/2006/chart">
   <roundedCorners val="0"/>
   <chart>
-    <title>
-      <tx>
-        <rich>
-          <a:bodyPr/>
-          <a:p>
-            <a:pPr>
-              <a:defRPr sz="1400" b="1" i="0">
-                <a:solidFill>
-                  <a:srgbClr val="0B0B0B"/>
-                </a:solidFill>
-                <a:latin typeface="Aptos Narrow"/>
-              </a:defRPr>
-            </a:pPr>
-            <a:r>
-              <a:rPr sz="1400" b="1" i="0">
-                <a:solidFill>
-                  <a:srgbClr val="0B0B0B"/>
-                </a:solidFill>
-                <a:latin typeface="Aptos Narrow"/>
-              </a:rPr>
-              <a:t>Harvest capacity vs tissue demand by quarter</a:t>
-            </a:r>
-          </a:p>
-          <a:p>
-            <a:pPr>
-              <a:defRPr sz="950" b="0" i="0">
-                <a:solidFill>
-                  <a:srgbClr val="7F7F7F"/>
-                </a:solidFill>
-                <a:latin typeface="Aptos Narrow"/>
-              </a:defRPr>
-            </a:pPr>
-            <a:r>
-              <a:rPr sz="950" b="0" i="0">
-                <a:solidFill>
-                  <a:srgbClr val="7F7F7F"/>
-                </a:solidFill>
-                <a:latin typeface="Aptos Narrow"/>
-              </a:rPr>
-              <a:t>Pigs per quarter, Q4'26-Q4'27. Blocks = net harvested; line = demand</a:t>
-            </a:r>
-          </a:p>
-          <a:p>
-            <a:pPr>
-              <a:defRPr sz="950" b="0" i="0">
-                <a:solidFill>
-                  <a:srgbClr val="7F7F7F"/>
-                </a:solidFill>
-                <a:latin typeface="Aptos Narrow"/>
-              </a:defRPr>
-            </a:pPr>
-            <a:r>
-              <a:rPr sz="950" b="0" i="0">
-                <a:solidFill>
-                  <a:srgbClr val="7F7F7F"/>
-                </a:solidFill>
-                <a:latin typeface="Aptos Narrow"/>
-              </a:rPr>
-              <a:t>Gray bands: net at spec (31,733) and gross kill (41,990)</a:t>
-            </a:r>
-          </a:p>
-        </rich>
-      </tx>
-      <layout>
-        <manualLayout>
-          <xMode val="edge"/>
-          <yMode val="edge"/>
-          <wMode val="factor"/>
-          <hMode val="factor"/>
-          <x val="0.005"/>
-          <y val="0.02"/>
-        </manualLayout>
-      </layout>
-      <overlay val="0"/>
-    </title>
+    <autoTitleDeleted val="1"/>
     <plotArea>
       <layout>
         <manualLayout>
@@ -1961,10 +1765,10 @@
           <yMode val="edge"/>
           <wMode val="factor"/>
           <hMode val="factor"/>
-          <x val="0.055"/>
-          <y val="0.2"/>
-          <w val="0.93"/>
-          <h val="0.6"/>
+          <x val="0.09"/>
+          <y val="0.05"/>
+          <w val="0.89"/>
+          <h val="0.78"/>
         </manualLayout>
       </layout>
       <barChart>
@@ -1973,140 +1777,6 @@
         <ser>
           <idx val="0"/>
           <order val="0"/>
-          <tx>
-            <v>Net at spec (context)</v>
-          </tx>
-          <spPr>
-            <a:solidFill>
-              <a:srgbClr val="B3B3B3"/>
-            </a:solidFill>
-            <a:ln>
-              <a:noFill/>
-              <a:prstDash val="solid"/>
-            </a:ln>
-          </spPr>
-          <cat>
-            <strRef>
-              <f>'Chart Data'!$B$4:$F$4</f>
-              <strCache>
-                <ptCount val="5"/>
-                <pt idx="0">
-                  <v>Q4'26</v>
-                </pt>
-                <pt idx="1">
-                  <v>Q1'27</v>
-                </pt>
-                <pt idx="2">
-                  <v>Q2'27</v>
-                </pt>
-                <pt idx="3">
-                  <v>Q3'27</v>
-                </pt>
-                <pt idx="4">
-                  <v>Q4'27</v>
-                </pt>
-              </strCache>
-            </strRef>
-          </cat>
-          <val>
-            <numRef>
-              <f>'Chart Data'!$B$9:$F$9</f>
-              <numCache>
-                <formatCode>General</formatCode>
-                <ptCount val="5"/>
-                <pt idx="0">
-                  <v>31732.9759753593</v>
-                </pt>
-                <pt idx="1">
-                  <v>31732.9759753593</v>
-                </pt>
-                <pt idx="2">
-                  <v>31732.9759753593</v>
-                </pt>
-                <pt idx="3">
-                  <v>31732.9759753593</v>
-                </pt>
-                <pt idx="4">
-                  <v>31732.9759753593</v>
-                </pt>
-              </numCache>
-            </numRef>
-          </val>
-        </ser>
-        <ser>
-          <idx val="1"/>
-          <order val="1"/>
-          <tx>
-            <v>Gross above spec (context)</v>
-          </tx>
-          <spPr>
-            <a:solidFill>
-              <a:srgbClr val="D9D9D9"/>
-            </a:solidFill>
-            <a:ln>
-              <a:noFill/>
-              <a:prstDash val="solid"/>
-            </a:ln>
-          </spPr>
-          <cat>
-            <strRef>
-              <f>'Chart Data'!$B$4:$F$4</f>
-              <strCache>
-                <ptCount val="5"/>
-                <pt idx="0">
-                  <v>Q4'26</v>
-                </pt>
-                <pt idx="1">
-                  <v>Q1'27</v>
-                </pt>
-                <pt idx="2">
-                  <v>Q2'27</v>
-                </pt>
-                <pt idx="3">
-                  <v>Q3'27</v>
-                </pt>
-                <pt idx="4">
-                  <v>Q4'27</v>
-                </pt>
-              </strCache>
-            </strRef>
-          </cat>
-          <val>
-            <numRef>
-              <f>'Chart Data'!$B$16:$F$16</f>
-              <numCache>
-                <formatCode>General</formatCode>
-                <ptCount val="5"/>
-                <pt idx="0">
-                  <v>10257.0240246407</v>
-                </pt>
-                <pt idx="1">
-                  <v>10257.0240246407</v>
-                </pt>
-                <pt idx="2">
-                  <v>10257.0240246407</v>
-                </pt>
-                <pt idx="3">
-                  <v>10257.0240246407</v>
-                </pt>
-                <pt idx="4">
-                  <v>10257.0240246407</v>
-                </pt>
-              </numCache>
-            </numRef>
-          </val>
-        </ser>
-        <gapWidth val="40"/>
-        <overlap val="100"/>
-        <axId val="10"/>
-        <axId val="100"/>
-      </barChart>
-      <barChart>
-        <barDir val="col"/>
-        <grouping val="stacked"/>
-        <ser>
-          <idx val="2"/>
-          <order val="2"/>
           <tx>
             <strRef>
               <f>Sheet1!$D$16</f>
@@ -2146,7 +1816,7 @@
               <a:bodyPr/>
               <a:p>
                 <a:pPr>
-                  <a:defRPr sz="1000" b="1" i="0">
+                  <a:defRPr sz="1300" b="1" i="0">
                     <a:solidFill>
                       <a:srgbClr val="FFFFFF"/>
                     </a:solidFill>
@@ -2156,713 +1826,7 @@
                 <a:r>
                   <a:t/>
                 </a:r>
-                <a:endParaRPr sz="1000" b="1" i="0">
-                  <a:solidFill>
-                    <a:srgbClr val="FFFFFF"/>
-                  </a:solidFill>
-                  <a:latin typeface="Aptos Narrow"/>
-                </a:endParaRPr>
-              </a:p>
-            </txPr>
-            <showLegendKey val="0"/>
-            <showVal val="0"/>
-            <showCatName val="0"/>
-            <showSerName val="0"/>
-            <showPercent val="0"/>
-            <showBubbleSize val="0"/>
-          </dLbls>
-          <val>
-            <numRef>
-              <f>'Chart Data'!$B$10:$F$10</f>
-              <numCache>
-                <formatCode>General</formatCode>
-                <ptCount val="5"/>
-                <pt idx="0">
-                  <v>17220.7857529863</v>
-                </pt>
-                <pt idx="1">
-                  <v>17220.7857529863</v>
-                </pt>
-                <pt idx="2">
-                  <v>17220.7857529863</v>
-                </pt>
-                <pt idx="3">
-                  <v>17220.7857529863</v>
-                </pt>
-                <pt idx="4">
-                  <v>17220.7857529863</v>
-                </pt>
-              </numCache>
-            </numRef>
-          </val>
-        </ser>
-        <ser>
-          <idx val="3"/>
-          <order val="3"/>
-          <tx>
-            <strRef>
-              <f>Sheet1!$D$17</f>
-              <strCache>
-                <ptCount val="1"/>
-                <pt idx="0">
-                  <v>Nahunta</v>
-                </pt>
-              </strCache>
-            </strRef>
-          </tx>
-          <spPr>
-            <a:solidFill>
-              <a:srgbClr val="EB6834"/>
-            </a:solidFill>
-            <a:ln w="15875">
-              <a:solidFill>
-                <a:srgbClr val="FFFFFF"/>
-              </a:solidFill>
-              <a:prstDash val="solid"/>
-            </a:ln>
-          </spPr>
-          <val>
-            <numRef>
-              <f>'Chart Data'!$B$11:$F$11</f>
-              <numCache>
-                <formatCode>General</formatCode>
-                <ptCount val="5"/>
-                <pt idx="0">
-                  <v>1239.89657421501</v>
-                </pt>
-                <pt idx="1">
-                  <v>1239.89657421501</v>
-                </pt>
-                <pt idx="2">
-                  <v>1239.89657421501</v>
-                </pt>
-                <pt idx="3">
-                  <v>1239.89657421501</v>
-                </pt>
-                <pt idx="4">
-                  <v>1239.89657421501</v>
-                </pt>
-              </numCache>
-            </numRef>
-          </val>
-        </ser>
-        <ser>
-          <idx val="4"/>
-          <order val="4"/>
-          <tx>
-            <strRef>
-              <f>Sheet1!$D$18</f>
-              <strCache>
-                <ptCount val="1"/>
-                <pt idx="0">
-                  <v>Customs</v>
-                </pt>
-              </strCache>
-            </strRef>
-          </tx>
-          <spPr>
-            <a:solidFill>
-              <a:srgbClr val="1BAF7A"/>
-            </a:solidFill>
-            <a:ln w="15875">
-              <a:solidFill>
-                <a:srgbClr val="FFFFFF"/>
-              </a:solidFill>
-              <a:prstDash val="solid"/>
-            </a:ln>
-          </spPr>
-          <val>
-            <numRef>
-              <f>'Chart Data'!$B$12:$F$12</f>
-              <numCache>
-                <formatCode>General</formatCode>
-                <ptCount val="5"/>
-                <pt idx="0">
-                  <v>1033.24714517918</v>
-                </pt>
-                <pt idx="1">
-                  <v>1033.24714517918</v>
-                </pt>
-                <pt idx="2">
-                  <v>1033.24714517918</v>
-                </pt>
-                <pt idx="3">
-                  <v>1033.24714517918</v>
-                </pt>
-                <pt idx="4">
-                  <v>1033.24714517918</v>
-                </pt>
-              </numCache>
-            </numRef>
-          </val>
-        </ser>
-        <ser>
-          <idx val="5"/>
-          <order val="5"/>
-          <tx>
-            <strRef>
-              <f>Sheet1!$D$19</f>
-              <strCache>
-                <ptCount val="1"/>
-                <pt idx="0">
-                  <v>Parks</v>
-                </pt>
-              </strCache>
-            </strRef>
-          </tx>
-          <spPr>
-            <a:solidFill>
-              <a:srgbClr val="EDA100"/>
-            </a:solidFill>
-            <a:ln w="15875">
-              <a:solidFill>
-                <a:srgbClr val="FFFFFF"/>
-              </a:solidFill>
-              <a:prstDash val="solid"/>
-            </a:ln>
-          </spPr>
-          <val>
-            <numRef>
-              <f>'Chart Data'!$B$13:$F$13</f>
-              <numCache>
-                <formatCode>General</formatCode>
-                <ptCount val="5"/>
-                <pt idx="0">
-                  <v>2396.61114142236</v>
-                </pt>
-                <pt idx="1">
-                  <v>2396.61114142236</v>
-                </pt>
-                <pt idx="2">
-                  <v>2396.61114142236</v>
-                </pt>
-                <pt idx="3">
-                  <v>2396.61114142236</v>
-                </pt>
-                <pt idx="4">
-                  <v>2396.61114142236</v>
-                </pt>
-              </numCache>
-            </numRef>
-          </val>
-        </ser>
-        <gapWidth val="120"/>
-        <overlap val="100"/>
-        <axId val="10"/>
-        <axId val="200"/>
-      </barChart>
-      <lineChart>
-        <grouping val="standard"/>
-        <ser>
-          <idx val="6"/>
-          <order val="6"/>
-          <tx>
-            <v>Demand</v>
-          </tx>
-          <spPr>
-            <a:ln w="19050" cap="rnd">
-              <a:solidFill>
-                <a:srgbClr val="0B0B0B"/>
-              </a:solidFill>
-              <a:prstDash val="solid"/>
-            </a:ln>
-          </spPr>
-          <marker>
-            <symbol val="none"/>
-            <spPr>
-              <a:ln>
-                <a:prstDash val="solid"/>
-              </a:ln>
-            </spPr>
-          </marker>
-          <val>
-            <numRef>
-              <f>'Chart Data'!$B$21:$F$21</f>
-              <numCache>
-                <formatCode>General</formatCode>
-                <ptCount val="5"/>
-                <pt idx="0">
-                  <v>7305</v>
-                </pt>
-                <pt idx="1">
-                  <v>7810</v>
-                </pt>
-                <pt idx="2">
-                  <v>8225</v>
-                </pt>
-                <pt idx="3">
-                  <v>8425</v>
-                </pt>
-                <pt idx="4">
-                  <v>8434</v>
-                </pt>
-              </numCache>
-            </numRef>
-          </val>
-          <smooth val="0"/>
-        </ser>
-        <ser>
-          <idx val="7"/>
-          <order val="7"/>
-          <tx>
-            <v>Total</v>
-          </tx>
-          <spPr>
-            <a:ln>
-              <a:noFill/>
-              <a:prstDash val="solid"/>
-            </a:ln>
-          </spPr>
-          <marker>
-            <symbol val="none"/>
-            <spPr>
-              <a:ln>
-                <a:prstDash val="solid"/>
-              </a:ln>
-            </spPr>
-          </marker>
-          <dLbls>
-            <numFmt formatCode="#,##0"/>
-            <txPr>
-              <a:bodyPr/>
-              <a:p>
-                <a:pPr>
-                  <a:defRPr sz="900" b="1" i="0">
-                    <a:solidFill>
-                      <a:srgbClr val="0B0B0B"/>
-                    </a:solidFill>
-                    <a:latin typeface="Aptos Narrow"/>
-                  </a:defRPr>
-                </a:pPr>
-                <a:r>
-                  <a:t/>
-                </a:r>
-                <a:endParaRPr sz="900" b="1" i="0">
-                  <a:solidFill>
-                    <a:srgbClr val="0B0B0B"/>
-                  </a:solidFill>
-                  <a:latin typeface="Aptos Narrow"/>
-                </a:endParaRPr>
-              </a:p>
-            </txPr>
-            <dLblPos val="t"/>
-            <showLegendKey val="0"/>
-            <showVal val="1"/>
-            <showCatName val="0"/>
-            <showSerName val="0"/>
-            <showPercent val="0"/>
-            <showBubbleSize val="0"/>
-          </dLbls>
-          <val>
-            <numRef>
-              <f>'Chart Data'!$B$14:$F$14</f>
-              <numCache>
-                <formatCode>General</formatCode>
-                <ptCount val="5"/>
-                <pt idx="0">
-                  <v>21890.5406138028</v>
-                </pt>
-                <pt idx="1">
-                  <v>21890.5406138028</v>
-                </pt>
-                <pt idx="2">
-                  <v>21890.5406138028</v>
-                </pt>
-                <pt idx="3">
-                  <v>21890.5406138028</v>
-                </pt>
-                <pt idx="4">
-                  <v>21890.5406138028</v>
-                </pt>
-              </numCache>
-            </numRef>
-          </val>
-          <smooth val="0"/>
-        </ser>
-        <axId val="10"/>
-        <axId val="200"/>
-      </lineChart>
-      <lineChart>
-        <grouping val="standard"/>
-        <ser>
-          <idx val="8"/>
-          <order val="8"/>
-          <tx>
-            <v>Total</v>
-          </tx>
-          <spPr>
-            <a:ln>
-              <a:noFill/>
-              <a:prstDash val="solid"/>
-            </a:ln>
-          </spPr>
-          <marker>
-            <symbol val="none"/>
-            <spPr>
-              <a:ln>
-                <a:prstDash val="solid"/>
-              </a:ln>
-            </spPr>
-          </marker>
-          <dLbls>
-            <numFmt formatCode="#,##0"/>
-            <txPr>
-              <a:bodyPr/>
-              <a:p>
-                <a:pPr>
-                  <a:defRPr sz="900" b="1" i="0">
-                    <a:solidFill>
-                      <a:srgbClr val="0B0B0B"/>
-                    </a:solidFill>
-                    <a:latin typeface="Aptos Narrow"/>
-                  </a:defRPr>
-                </a:pPr>
-                <a:r>
-                  <a:t/>
-                </a:r>
-                <a:endParaRPr sz="900" b="1" i="0">
-                  <a:solidFill>
-                    <a:srgbClr val="0B0B0B"/>
-                  </a:solidFill>
-                  <a:latin typeface="Aptos Narrow"/>
-                </a:endParaRPr>
-              </a:p>
-            </txPr>
-            <dLblPos val="t"/>
-            <showLegendKey val="0"/>
-            <showVal val="1"/>
-            <showCatName val="0"/>
-            <showSerName val="0"/>
-            <showPercent val="0"/>
-            <showBubbleSize val="0"/>
-          </dLbls>
-          <val>
-            <numRef>
-              <f>'Chart Data'!$B$15:$F$15</f>
-              <numCache>
-                <formatCode>General</formatCode>
-                <ptCount val="5"/>
-                <pt idx="0">
-                  <v>41990</v>
-                </pt>
-                <pt idx="1">
-                  <v>41990</v>
-                </pt>
-                <pt idx="2">
-                  <v>41990</v>
-                </pt>
-                <pt idx="3">
-                  <v>41990</v>
-                </pt>
-                <pt idx="4">
-                  <v>41990</v>
-                </pt>
-              </numCache>
-            </numRef>
-          </val>
-          <smooth val="0"/>
-        </ser>
-        <axId val="10"/>
-        <axId val="100"/>
-      </lineChart>
-      <catAx>
-        <axId val="10"/>
-        <scaling>
-          <orientation val="minMax"/>
-        </scaling>
-        <delete val="0"/>
-        <axPos val="l"/>
-        <numFmt formatCode="@" sourceLinked="0"/>
-        <majorTickMark val="none"/>
-        <minorTickMark val="none"/>
-        <tickLblPos val="nextTo"/>
-        <spPr>
-          <a:ln w="9525">
-            <a:solidFill>
-              <a:srgbClr val="BFBFBF"/>
-            </a:solidFill>
-            <a:prstDash val="solid"/>
-          </a:ln>
-        </spPr>
-        <txPr>
-          <a:bodyPr/>
-          <a:p>
-            <a:pPr>
-              <a:defRPr sz="900" b="0" i="0">
-                <a:solidFill>
-                  <a:srgbClr val="595959"/>
-                </a:solidFill>
-                <a:latin typeface="Aptos Narrow"/>
-              </a:defRPr>
-            </a:pPr>
-            <a:r>
-              <a:t/>
-            </a:r>
-            <a:endParaRPr sz="900" b="0" i="0">
-              <a:solidFill>
-                <a:srgbClr val="595959"/>
-              </a:solidFill>
-              <a:latin typeface="Aptos Narrow"/>
-            </a:endParaRPr>
-          </a:p>
-        </txPr>
-        <crossAx val="100"/>
-        <lblOffset val="100"/>
-      </catAx>
-      <valAx>
-        <axId val="100"/>
-        <scaling>
-          <orientation val="minMax"/>
-          <max val="45000"/>
-          <min val="0"/>
-        </scaling>
-        <delete val="0"/>
-        <axPos val="l"/>
-        <majorGridlines>
-          <spPr>
-            <a:ln w="9525">
-              <a:solidFill>
-                <a:srgbClr val="E7E7E7"/>
-              </a:solidFill>
-              <a:prstDash val="solid"/>
-            </a:ln>
-          </spPr>
-        </majorGridlines>
-        <numFmt formatCode="#,##0" sourceLinked="0"/>
-        <majorTickMark val="none"/>
-        <minorTickMark val="none"/>
-        <tickLblPos val="nextTo"/>
-        <spPr>
-          <a:ln>
-            <a:noFill/>
-            <a:prstDash val="solid"/>
-          </a:ln>
-        </spPr>
-        <txPr>
-          <a:bodyPr/>
-          <a:p>
-            <a:pPr>
-              <a:defRPr sz="900" b="0" i="0">
-                <a:solidFill>
-                  <a:srgbClr val="595959"/>
-                </a:solidFill>
-                <a:latin typeface="Aptos Narrow"/>
-              </a:defRPr>
-            </a:pPr>
-            <a:r>
-              <a:t/>
-            </a:r>
-            <a:endParaRPr sz="900" b="0" i="0">
-              <a:solidFill>
-                <a:srgbClr val="595959"/>
-              </a:solidFill>
-              <a:latin typeface="Aptos Narrow"/>
-            </a:endParaRPr>
-          </a:p>
-        </txPr>
-        <crossAx val="10"/>
-        <majorUnit val="10000"/>
-      </valAx>
-      <valAx>
-        <axId val="200"/>
-        <scaling>
-          <orientation val="minMax"/>
-          <max val="45000"/>
-          <min val="0"/>
-        </scaling>
-        <delete val="1"/>
-        <axPos val="l"/>
-        <numFmt formatCode="#,##0" sourceLinked="0"/>
-        <majorTickMark val="none"/>
-        <minorTickMark val="none"/>
-        <crossAx val="10"/>
-      </valAx>
-    </plotArea>
-    <legend>
-      <legendPos val="b"/>
-      <legendEntry>
-        <idx val="0"/>
-        <delete val="1"/>
-      </legendEntry>
-      <legendEntry>
-        <idx val="1"/>
-        <delete val="1"/>
-      </legendEntry>
-      <legendEntry>
-        <idx val="7"/>
-        <delete val="1"/>
-      </legendEntry>
-      <legendEntry>
-        <idx val="8"/>
-        <delete val="1"/>
-      </legendEntry>
-      <overlay val="0"/>
-      <txPr>
-        <a:bodyPr/>
-        <a:p>
-          <a:pPr>
-            <a:defRPr sz="900" b="0" i="0">
-              <a:solidFill>
-                <a:srgbClr val="595959"/>
-              </a:solidFill>
-              <a:latin typeface="Aptos Narrow"/>
-            </a:defRPr>
-          </a:pPr>
-          <a:r>
-            <a:t/>
-          </a:r>
-          <a:endParaRPr sz="900" b="0" i="0">
-            <a:solidFill>
-              <a:srgbClr val="595959"/>
-            </a:solidFill>
-            <a:latin typeface="Aptos Narrow"/>
-          </a:endParaRPr>
-        </a:p>
-      </txPr>
-    </legend>
-    <plotVisOnly val="1"/>
-    <dispBlanksAs val="gap"/>
-  </chart>
-  <spPr xmlns:a="http://schemas.openxmlformats.org/drawingml/2006/main">
-    <a:ln>
-      <a:noFill/>
-    </a:ln>
-  </spPr>
-  <externalData xmlns:r="http://schemas.openxmlformats.org/officeDocument/2006/relationships" r:id="rId1">
-    <autoUpdate val="0"/>
-  </externalData>
-</chartSpace>
-</file>
-
-<file path=ppt/charts/chart4.xml><?xml version="1.0" encoding="utf-8"?>
-<chartSpace xmlns:a="http://schemas.openxmlformats.org/drawingml/2006/main" xmlns="http://schemas.openxmlformats.org/drawingml/2006/chart">
-  <roundedCorners val="0"/>
-  <chart>
-    <title>
-      <tx>
-        <rich>
-          <a:bodyPr/>
-          <a:p>
-            <a:pPr>
-              <a:defRPr sz="1250" b="1" i="0">
-                <a:solidFill>
-                  <a:srgbClr val="0B0B0B"/>
-                </a:solidFill>
-                <a:latin typeface="Aptos Narrow"/>
-              </a:defRPr>
-            </a:pPr>
-            <a:r>
-              <a:rPr sz="1250" b="1" i="0">
-                <a:solidFill>
-                  <a:srgbClr val="0B0B0B"/>
-                </a:solidFill>
-                <a:latin typeface="Aptos Narrow"/>
-              </a:rPr>
-              <a:t>Zoom: demand vs net harvested capacity</a:t>
-            </a:r>
-          </a:p>
-          <a:p>
-            <a:pPr>
-              <a:defRPr sz="900" b="0" i="0">
-                <a:solidFill>
-                  <a:srgbClr val="7F7F7F"/>
-                </a:solidFill>
-                <a:latin typeface="Aptos Narrow"/>
-              </a:defRPr>
-            </a:pPr>
-            <a:r>
-              <a:rPr sz="900" b="0" i="0">
-                <a:solidFill>
-                  <a:srgbClr val="7F7F7F"/>
-                </a:solidFill>
-                <a:latin typeface="Aptos Narrow"/>
-              </a:rPr>
-              <a:t>Same data, y-axis capped at 25K; gray levels sit above</a:t>
-            </a:r>
-          </a:p>
-        </rich>
-      </tx>
-      <layout>
-        <manualLayout>
-          <xMode val="edge"/>
-          <yMode val="edge"/>
-          <wMode val="factor"/>
-          <hMode val="factor"/>
-          <x val="0.005"/>
-          <y val="0.02"/>
-        </manualLayout>
-      </layout>
-      <overlay val="0"/>
-    </title>
-    <plotArea>
-      <layout>
-        <manualLayout>
-          <xMode val="edge"/>
-          <yMode val="edge"/>
-          <wMode val="factor"/>
-          <hMode val="factor"/>
-          <x val="0.09"/>
-          <y val="0.2"/>
-          <w val="0.89"/>
-          <h val="0.6"/>
-        </manualLayout>
-      </layout>
-      <barChart>
-        <barDir val="col"/>
-        <grouping val="stacked"/>
-        <ser>
-          <idx val="0"/>
-          <order val="0"/>
-          <tx>
-            <strRef>
-              <f>Sheet1!$D$16</f>
-              <strCache>
-                <ptCount val="1"/>
-                <pt idx="0">
-                  <v>Martins</v>
-                </pt>
-              </strCache>
-            </strRef>
-          </tx>
-          <spPr>
-            <a:solidFill>
-              <a:srgbClr val="2A78D6"/>
-            </a:solidFill>
-            <a:ln w="15875">
-              <a:solidFill>
-                <a:srgbClr val="FFFFFF"/>
-              </a:solidFill>
-              <a:prstDash val="solid"/>
-            </a:ln>
-          </spPr>
-          <dLbls>
-            <dLbl>
-              <idx val="0"/>
-              <numFmt formatCode="#,##0"/>
-              <dLblPos val="ctr"/>
-              <showLegendKey val="0"/>
-              <showVal val="1"/>
-              <showCatName val="0"/>
-              <showSerName val="0"/>
-              <showPercent val="0"/>
-              <showBubbleSize val="0"/>
-            </dLbl>
-            <numFmt formatCode="#,##0"/>
-            <txPr>
-              <a:bodyPr/>
-              <a:p>
-                <a:pPr>
-                  <a:defRPr sz="1000" b="1" i="0">
-                    <a:solidFill>
-                      <a:srgbClr val="FFFFFF"/>
-                    </a:solidFill>
-                    <a:latin typeface="Aptos Narrow"/>
-                  </a:defRPr>
-                </a:pPr>
-                <a:r>
-                  <a:t/>
-                </a:r>
-                <a:endParaRPr sz="1000" b="1" i="0">
+                <a:endParaRPr sz="1300" b="1" i="0">
                   <a:solidFill>
                     <a:srgbClr val="FFFFFF"/>
                   </a:solidFill>
@@ -3190,7 +2154,7 @@
               <a:bodyPr/>
               <a:p>
                 <a:pPr>
-                  <a:defRPr sz="950" b="1" i="0">
+                  <a:defRPr sz="1250" b="1" i="0">
                     <a:solidFill>
                       <a:srgbClr val="FFFFFF"/>
                     </a:solidFill>
@@ -3200,7 +2164,7 @@
                 <a:r>
                   <a:t/>
                 </a:r>
-                <a:endParaRPr sz="950" b="1" i="0">
+                <a:endParaRPr sz="1250" b="1" i="0">
                   <a:solidFill>
                     <a:srgbClr val="FFFFFF"/>
                   </a:solidFill>
@@ -3267,7 +2231,7 @@
               <a:bodyPr/>
               <a:p>
                 <a:pPr>
-                  <a:defRPr sz="900" b="1" i="0">
+                  <a:defRPr sz="1150" b="1" i="0">
                     <a:solidFill>
                       <a:srgbClr val="0B0B0B"/>
                     </a:solidFill>
@@ -3277,7 +2241,7 @@
                 <a:r>
                   <a:t/>
                 </a:r>
-                <a:endParaRPr sz="900" b="1" i="0">
+                <a:endParaRPr sz="1150" b="1" i="0">
                   <a:solidFill>
                     <a:srgbClr val="0B0B0B"/>
                   </a:solidFill>
@@ -3345,7 +2309,7 @@
           <a:bodyPr/>
           <a:p>
             <a:pPr>
-              <a:defRPr sz="900" b="0" i="0">
+              <a:defRPr sz="1150" b="0" i="0">
                 <a:solidFill>
                   <a:srgbClr val="595959"/>
                 </a:solidFill>
@@ -3355,7 +2319,7 @@
             <a:r>
               <a:t/>
             </a:r>
-            <a:endParaRPr sz="900" b="0" i="0">
+            <a:endParaRPr sz="1150" b="0" i="0">
               <a:solidFill>
                 <a:srgbClr val="595959"/>
               </a:solidFill>
@@ -3385,7 +2349,7 @@
             </a:ln>
           </spPr>
         </majorGridlines>
-        <numFmt formatCode="#,##0" sourceLinked="0"/>
+        <numFmt formatCode="[=0]0;#,##0,&quot;K&quot;" sourceLinked="0"/>
         <majorTickMark val="none"/>
         <minorTickMark val="none"/>
         <tickLblPos val="nextTo"/>
@@ -3399,7 +2363,7 @@
           <a:bodyPr/>
           <a:p>
             <a:pPr>
-              <a:defRPr sz="900" b="0" i="0">
+              <a:defRPr sz="1150" b="0" i="0">
                 <a:solidFill>
                   <a:srgbClr val="595959"/>
                 </a:solidFill>
@@ -3409,7 +2373,7 @@
             <a:r>
               <a:t/>
             </a:r>
-            <a:endParaRPr sz="900" b="0" i="0">
+            <a:endParaRPr sz="1150" b="0" i="0">
               <a:solidFill>
                 <a:srgbClr val="595959"/>
               </a:solidFill>
@@ -3432,7 +2396,7 @@
         <a:bodyPr/>
         <a:p>
           <a:pPr>
-            <a:defRPr sz="900" b="0" i="0">
+            <a:defRPr sz="1150" b="0" i="0">
               <a:solidFill>
                 <a:srgbClr val="595959"/>
               </a:solidFill>
@@ -3442,7 +2406,7 @@
           <a:r>
             <a:t/>
           </a:r>
-          <a:endParaRPr sz="900" b="0" i="0">
+          <a:endParaRPr sz="1150" b="0" i="0">
             <a:solidFill>
               <a:srgbClr val="595959"/>
             </a:solidFill>
@@ -3465,66 +2429,11 @@
 </chartSpace>
 </file>
 
-<file path=ppt/charts/chart5.xml><?xml version="1.0" encoding="utf-8"?>
+<file path=ppt/charts/chart4.xml><?xml version="1.0" encoding="utf-8"?>
 <chartSpace xmlns:a="http://schemas.openxmlformats.org/drawingml/2006/main" xmlns="http://schemas.openxmlformats.org/drawingml/2006/chart">
   <roundedCorners val="0"/>
   <chart>
-    <title>
-      <tx>
-        <rich>
-          <a:bodyPr/>
-          <a:p>
-            <a:pPr>
-              <a:defRPr sz="1200" b="1" i="0">
-                <a:solidFill>
-                  <a:srgbClr val="0B0B0B"/>
-                </a:solidFill>
-                <a:latin typeface="Aptos Narrow"/>
-              </a:defRPr>
-            </a:pPr>
-            <a:r>
-              <a:rPr sz="1200" b="1" i="0">
-                <a:solidFill>
-                  <a:srgbClr val="0B0B0B"/>
-                </a:solidFill>
-                <a:latin typeface="Aptos Narrow"/>
-              </a:rPr>
-              <a:t>Capacity funnel vs peak demand</a:t>
-            </a:r>
-          </a:p>
-          <a:p>
-            <a:pPr>
-              <a:defRPr sz="900" b="0" i="0">
-                <a:solidFill>
-                  <a:srgbClr val="7F7F7F"/>
-                </a:solidFill>
-                <a:latin typeface="Aptos Narrow"/>
-              </a:defRPr>
-            </a:pPr>
-            <a:r>
-              <a:rPr sz="900" b="0" i="0">
-                <a:solidFill>
-                  <a:srgbClr val="7F7F7F"/>
-                </a:solidFill>
-                <a:latin typeface="Aptos Narrow"/>
-              </a:rPr>
-              <a:t>Pigs per quarter by slaughterhouse, flat; demand bar = Q4'27 peak.</a:t>
-            </a:r>
-          </a:p>
-        </rich>
-      </tx>
-      <layout>
-        <manualLayout>
-          <xMode val="edge"/>
-          <yMode val="edge"/>
-          <wMode val="factor"/>
-          <hMode val="factor"/>
-          <x val="0.005"/>
-          <y val="0.02"/>
-        </manualLayout>
-      </layout>
-      <overlay val="0"/>
-    </title>
+    <autoTitleDeleted val="1"/>
     <plotArea>
       <layout>
         <manualLayout>
@@ -3533,9 +2442,9 @@
           <wMode val="factor"/>
           <hMode val="factor"/>
           <x val="0.055"/>
-          <y val="0.18"/>
+          <y val="0.05"/>
           <w val="0.93"/>
-          <h val="0.58"/>
+          <h val="0.78"/>
         </manualLayout>
       </layout>
       <barChart>
@@ -3566,38 +2475,6 @@
               <a:prstDash val="solid"/>
             </a:ln>
           </spPr>
-          <dLbls>
-            <numFmt formatCode="#,##0"/>
-            <txPr>
-              <a:bodyPr/>
-              <a:p>
-                <a:pPr>
-                  <a:defRPr sz="900" b="1" i="0">
-                    <a:solidFill>
-                      <a:srgbClr val="FFFFFF"/>
-                    </a:solidFill>
-                    <a:latin typeface="Aptos Narrow"/>
-                  </a:defRPr>
-                </a:pPr>
-                <a:r>
-                  <a:t/>
-                </a:r>
-                <a:endParaRPr sz="900" b="1" i="0">
-                  <a:solidFill>
-                    <a:srgbClr val="FFFFFF"/>
-                  </a:solidFill>
-                  <a:latin typeface="Aptos Narrow"/>
-                </a:endParaRPr>
-              </a:p>
-            </txPr>
-            <dLblPos val="ctr"/>
-            <showLegendKey val="0"/>
-            <showVal val="1"/>
-            <showCatName val="0"/>
-            <showSerName val="0"/>
-            <showPercent val="0"/>
-            <showBubbleSize val="0"/>
-          </dLbls>
           <cat>
             <strRef>
               <f>'Chart Data'!$I$4:$L$4</f>
@@ -3876,7 +2753,7 @@
               <a:bodyPr/>
               <a:p>
                 <a:pPr>
-                  <a:defRPr sz="900" b="1" i="0">
+                  <a:defRPr sz="1150" b="1" i="0">
                     <a:solidFill>
                       <a:srgbClr val="FFFFFF"/>
                     </a:solidFill>
@@ -3886,7 +2763,7 @@
                 <a:r>
                   <a:t/>
                 </a:r>
-                <a:endParaRPr sz="900" b="1" i="0">
+                <a:endParaRPr sz="1150" b="1" i="0">
                   <a:solidFill>
                     <a:srgbClr val="FFFFFF"/>
                   </a:solidFill>
@@ -3967,7 +2844,7 @@
           <a:bodyPr/>
           <a:p>
             <a:pPr>
-              <a:defRPr sz="900" b="0" i="0">
+              <a:defRPr sz="1150" b="0" i="0">
                 <a:solidFill>
                   <a:srgbClr val="595959"/>
                 </a:solidFill>
@@ -3977,7 +2854,7 @@
             <a:r>
               <a:t/>
             </a:r>
-            <a:endParaRPr sz="900" b="0" i="0">
+            <a:endParaRPr sz="1150" b="0" i="0">
               <a:solidFill>
                 <a:srgbClr val="595959"/>
               </a:solidFill>
@@ -4007,7 +2884,7 @@
             </a:ln>
           </spPr>
         </majorGridlines>
-        <numFmt formatCode="#,##0" sourceLinked="0"/>
+        <numFmt formatCode="[=0]0;#,##0,&quot;K&quot;" sourceLinked="0"/>
         <majorTickMark val="none"/>
         <minorTickMark val="none"/>
         <tickLblPos val="nextTo"/>
@@ -4021,7 +2898,7 @@
           <a:bodyPr/>
           <a:p>
             <a:pPr>
-              <a:defRPr sz="900" b="0" i="0">
+              <a:defRPr sz="1150" b="0" i="0">
                 <a:solidFill>
                   <a:srgbClr val="595959"/>
                 </a:solidFill>
@@ -4031,7 +2908,7 @@
             <a:r>
               <a:t/>
             </a:r>
-            <a:endParaRPr sz="900" b="0" i="0">
+            <a:endParaRPr sz="1150" b="0" i="0">
               <a:solidFill>
                 <a:srgbClr val="595959"/>
               </a:solidFill>
@@ -4050,7 +2927,7 @@
         <a:bodyPr/>
         <a:p>
           <a:pPr>
-            <a:defRPr sz="900" b="0" i="0">
+            <a:defRPr sz="1150" b="0" i="0">
               <a:solidFill>
                 <a:srgbClr val="595959"/>
               </a:solidFill>
@@ -4060,7 +2937,7 @@
           <a:r>
             <a:t/>
           </a:r>
-          <a:endParaRPr sz="900" b="0" i="0">
+          <a:endParaRPr sz="1150" b="0" i="0">
             <a:solidFill>
               <a:srgbClr val="595959"/>
             </a:solidFill>
@@ -4083,66 +2960,11 @@
 </chartSpace>
 </file>
 
-<file path=ppt/charts/chart6.xml><?xml version="1.0" encoding="utf-8"?>
+<file path=ppt/charts/chart5.xml><?xml version="1.0" encoding="utf-8"?>
 <chartSpace xmlns:a="http://schemas.openxmlformats.org/drawingml/2006/main" xmlns="http://schemas.openxmlformats.org/drawingml/2006/chart">
   <roundedCorners val="0"/>
   <chart>
-    <title>
-      <tx>
-        <rich>
-          <a:bodyPr/>
-          <a:p>
-            <a:pPr>
-              <a:defRPr sz="1200" b="1" i="0">
-                <a:solidFill>
-                  <a:srgbClr val="0B0B0B"/>
-                </a:solidFill>
-                <a:latin typeface="Aptos Narrow"/>
-              </a:defRPr>
-            </a:pPr>
-            <a:r>
-              <a:rPr sz="1200" b="1" i="0">
-                <a:solidFill>
-                  <a:srgbClr val="0B0B0B"/>
-                </a:solidFill>
-                <a:latin typeface="Aptos Narrow"/>
-              </a:rPr>
-              <a:t>Tissue demand by part vs harvested capacity</a:t>
-            </a:r>
-          </a:p>
-          <a:p>
-            <a:pPr>
-              <a:defRPr sz="900" b="0" i="0">
-                <a:solidFill>
-                  <a:srgbClr val="7F7F7F"/>
-                </a:solidFill>
-                <a:latin typeface="Aptos Narrow"/>
-              </a:defRPr>
-            </a:pPr>
-            <a:r>
-              <a:rPr sz="900" b="0" i="0">
-                <a:solidFill>
-                  <a:srgbClr val="7F7F7F"/>
-                </a:solidFill>
-                <a:latin typeface="Aptos Narrow"/>
-              </a:rPr>
-              <a:t>Pigs per quarter; gray line = net harvested capacity (21,891/qtr).</a:t>
-            </a:r>
-          </a:p>
-        </rich>
-      </tx>
-      <layout>
-        <manualLayout>
-          <xMode val="edge"/>
-          <yMode val="edge"/>
-          <wMode val="factor"/>
-          <hMode val="factor"/>
-          <x val="0.005"/>
-          <y val="0.02"/>
-        </manualLayout>
-      </layout>
-      <overlay val="0"/>
-    </title>
+    <autoTitleDeleted val="1"/>
     <plotArea>
       <layout>
         <manualLayout>
@@ -4151,9 +2973,9 @@
           <wMode val="factor"/>
           <hMode val="factor"/>
           <x val="0.055"/>
-          <y val="0.18"/>
+          <y val="0.05"/>
           <w val="0.93"/>
-          <h val="0.58"/>
+          <h val="0.78"/>
         </manualLayout>
       </layout>
       <barChart>
@@ -4168,7 +2990,7 @@
               <strCache>
                 <ptCount val="1"/>
                 <pt idx="0">
-                  <v>666501</v>
+                  <v>Part 666501</v>
                 </pt>
               </strCache>
             </strRef>
@@ -4241,7 +3063,7 @@
               <strCache>
                 <ptCount val="1"/>
                 <pt idx="0">
-                  <v>666502</v>
+                  <v>Part 666502</v>
                 </pt>
               </strCache>
             </strRef>
@@ -4314,7 +3136,7 @@
               <strCache>
                 <ptCount val="1"/>
                 <pt idx="0">
-                  <v>666506</v>
+                  <v>Part 666506</v>
                 </pt>
               </strCache>
             </strRef>
@@ -4387,7 +3209,7 @@
               <strCache>
                 <ptCount val="1"/>
                 <pt idx="0">
-                  <v>666541</v>
+                  <v>Part 666541</v>
                 </pt>
               </strCache>
             </strRef>
@@ -4497,7 +3319,7 @@
               <a:bodyPr/>
               <a:p>
                 <a:pPr>
-                  <a:defRPr sz="900" b="1" i="0">
+                  <a:defRPr sz="1150" b="1" i="0">
                     <a:solidFill>
                       <a:srgbClr val="595959"/>
                     </a:solidFill>
@@ -4507,7 +3329,7 @@
                 <a:r>
                   <a:t/>
                 </a:r>
-                <a:endParaRPr sz="900" b="1" i="0">
+                <a:endParaRPr sz="1150" b="1" i="0">
                   <a:solidFill>
                     <a:srgbClr val="595959"/>
                   </a:solidFill>
@@ -4574,7 +3396,7 @@
               <a:bodyPr/>
               <a:p>
                 <a:pPr>
-                  <a:defRPr sz="900" b="0" i="0">
+                  <a:defRPr sz="1150" b="0" i="0">
                     <a:solidFill>
                       <a:srgbClr val="404040"/>
                     </a:solidFill>
@@ -4584,7 +3406,7 @@
                 <a:r>
                   <a:t/>
                 </a:r>
-                <a:endParaRPr sz="900" b="0" i="0">
+                <a:endParaRPr sz="1150" b="0" i="0">
                   <a:solidFill>
                     <a:srgbClr val="404040"/>
                   </a:solidFill>
@@ -4652,7 +3474,7 @@
           <a:bodyPr/>
           <a:p>
             <a:pPr>
-              <a:defRPr sz="900" b="0" i="0">
+              <a:defRPr sz="1150" b="0" i="0">
                 <a:solidFill>
                   <a:srgbClr val="595959"/>
                 </a:solidFill>
@@ -4662,7 +3484,7 @@
             <a:r>
               <a:t/>
             </a:r>
-            <a:endParaRPr sz="900" b="0" i="0">
+            <a:endParaRPr sz="1150" b="0" i="0">
               <a:solidFill>
                 <a:srgbClr val="595959"/>
               </a:solidFill>
@@ -4692,7 +3514,7 @@
             </a:ln>
           </spPr>
         </majorGridlines>
-        <numFmt formatCode="#,##0" sourceLinked="0"/>
+        <numFmt formatCode="[=0]0;#,##0,&quot;K&quot;" sourceLinked="0"/>
         <majorTickMark val="none"/>
         <minorTickMark val="none"/>
         <tickLblPos val="nextTo"/>
@@ -4706,7 +3528,7 @@
           <a:bodyPr/>
           <a:p>
             <a:pPr>
-              <a:defRPr sz="900" b="0" i="0">
+              <a:defRPr sz="1150" b="0" i="0">
                 <a:solidFill>
                   <a:srgbClr val="595959"/>
                 </a:solidFill>
@@ -4716,7 +3538,7 @@
             <a:r>
               <a:t/>
             </a:r>
-            <a:endParaRPr sz="900" b="0" i="0">
+            <a:endParaRPr sz="1150" b="0" i="0">
               <a:solidFill>
                 <a:srgbClr val="595959"/>
               </a:solidFill>
@@ -4730,10 +3552,6 @@
     </plotArea>
     <legend>
       <legendPos val="b"/>
-      <legendEntry>
-        <idx val="4"/>
-        <delete val="1"/>
-      </legendEntry>
       <legendEntry>
         <idx val="5"/>
         <delete val="1"/>
@@ -4743,7 +3561,7 @@
         <a:bodyPr/>
         <a:p>
           <a:pPr>
-            <a:defRPr sz="900" b="0" i="0">
+            <a:defRPr sz="1150" b="0" i="0">
               <a:solidFill>
                 <a:srgbClr val="595959"/>
               </a:solidFill>
@@ -4753,7 +3571,7 @@
           <a:r>
             <a:t/>
           </a:r>
-          <a:endParaRPr sz="900" b="0" i="0">
+          <a:endParaRPr sz="1150" b="0" i="0">
             <a:solidFill>
               <a:srgbClr val="595959"/>
             </a:solidFill>
@@ -7750,6 +6568,14 @@
 <file path=ppt/slides/slide1.xml><?xml version="1.0" encoding="utf-8"?>
 <p:sld xmlns:a="http://schemas.openxmlformats.org/drawingml/2006/main" xmlns:p="http://schemas.openxmlformats.org/presentationml/2006/main" xmlns:r="http://schemas.openxmlformats.org/officeDocument/2006/relationships">
   <p:cSld>
+    <p:bg>
+      <p:bgPr>
+        <a:solidFill>
+          <a:srgbClr val="0B0B0B"/>
+        </a:solidFill>
+        <a:effectLst/>
+      </p:bgPr>
+    </p:bg>
     <p:spTree>
       <p:nvGrpSpPr>
         <p:cNvPr id="1" name=""/>
@@ -7757,24 +6583,391 @@
         <p:nvPr/>
       </p:nvGrpSpPr>
       <p:grpSpPr/>
-      <p:graphicFrame>
-        <p:nvGraphicFramePr>
-          <p:cNvPr id="2" name="Chart 1"/>
-          <p:cNvGraphicFramePr>
-            <a:graphicFrameLocks noGrp="1"/>
-          </p:cNvGraphicFramePr>
+      <p:sp>
+        <p:nvSpPr>
+          <p:cNvPr id="2" name="TextBox 1"/>
+          <p:cNvSpPr txBox="1"/>
           <p:nvPr/>
-        </p:nvGraphicFramePr>
-        <p:xfrm>
-          <a:off x="365760" y="228600"/>
-          <a:ext cx="11457432" cy="6400800"/>
-        </p:xfrm>
-        <a:graphic>
-          <a:graphicData uri="http://schemas.openxmlformats.org/drawingml/2006/chart">
-            <c:chart xmlns:c="http://schemas.openxmlformats.org/drawingml/2006/chart" r:id="rId2"/>
-          </a:graphicData>
-        </a:graphic>
-      </p:graphicFrame>
+        </p:nvSpPr>
+        <p:spPr>
+          <a:xfrm>
+            <a:off x="822960" y="1691640"/>
+            <a:ext cx="10515600" cy="365760"/>
+          </a:xfrm>
+          <a:prstGeom prst="rect">
+            <a:avLst/>
+          </a:prstGeom>
+          <a:noFill/>
+        </p:spPr>
+        <p:txBody>
+          <a:bodyPr wrap="square" lIns="0" rIns="0" tIns="0" bIns="0">
+            <a:spAutoFit/>
+          </a:bodyPr>
+          <a:lstStyle/>
+          <a:p>
+            <a:pPr algn="l"/>
+            <a:r>
+              <a:rPr sz="1300" b="1">
+                <a:solidFill>
+                  <a:srgbClr val="6FA8EA"/>
+                </a:solidFill>
+                <a:latin typeface="Aptos Narrow"/>
+              </a:rPr>
+              <a:t>PVA SECOND SUPPLIER INITIATIVE</a:t>
+            </a:r>
+          </a:p>
+        </p:txBody>
+      </p:sp>
+      <p:sp>
+        <p:nvSpPr>
+          <p:cNvPr id="3" name="TextBox 2"/>
+          <p:cNvSpPr txBox="1"/>
+          <p:nvPr/>
+        </p:nvSpPr>
+        <p:spPr>
+          <a:xfrm>
+            <a:off x="822960" y="2103120"/>
+            <a:ext cx="10515600" cy="914400"/>
+          </a:xfrm>
+          <a:prstGeom prst="rect">
+            <a:avLst/>
+          </a:prstGeom>
+          <a:noFill/>
+        </p:spPr>
+        <p:txBody>
+          <a:bodyPr wrap="square" lIns="0" rIns="0" tIns="0" bIns="0">
+            <a:spAutoFit/>
+          </a:bodyPr>
+          <a:lstStyle/>
+          <a:p>
+            <a:pPr algn="l"/>
+            <a:r>
+              <a:rPr sz="4000" b="1">
+                <a:solidFill>
+                  <a:srgbClr val="FFFFFF"/>
+                </a:solidFill>
+                <a:latin typeface="Aptos Narrow"/>
+              </a:rPr>
+              <a:t>Pig tissue supply vs demand</a:t>
+            </a:r>
+          </a:p>
+        </p:txBody>
+      </p:sp>
+      <p:sp>
+        <p:nvSpPr>
+          <p:cNvPr id="4" name="TextBox 3"/>
+          <p:cNvSpPr txBox="1"/>
+          <p:nvPr/>
+        </p:nvSpPr>
+        <p:spPr>
+          <a:xfrm>
+            <a:off x="822960" y="3017520"/>
+            <a:ext cx="10515600" cy="457200"/>
+          </a:xfrm>
+          <a:prstGeom prst="rect">
+            <a:avLst/>
+          </a:prstGeom>
+          <a:noFill/>
+        </p:spPr>
+        <p:txBody>
+          <a:bodyPr wrap="square" lIns="0" rIns="0" tIns="0" bIns="0">
+            <a:spAutoFit/>
+          </a:bodyPr>
+          <a:lstStyle/>
+          <a:p>
+            <a:pPr algn="l"/>
+            <a:r>
+              <a:rPr sz="1600" b="0">
+                <a:solidFill>
+                  <a:srgbClr val="C9C9C9"/>
+                </a:solidFill>
+                <a:latin typeface="Aptos Narrow"/>
+              </a:rPr>
+              <a:t>Slaughterhouse capacity against tissue demand, Q4'26–Q4'27 — all figures in pigs per quarter</a:t>
+            </a:r>
+          </a:p>
+        </p:txBody>
+      </p:sp>
+      <p:sp>
+        <p:nvSpPr>
+          <p:cNvPr id="5" name="TextBox 4"/>
+          <p:cNvSpPr txBox="1"/>
+          <p:nvPr/>
+        </p:nvSpPr>
+        <p:spPr>
+          <a:xfrm>
+            <a:off x="822960" y="4160520"/>
+            <a:ext cx="2560320" cy="548640"/>
+          </a:xfrm>
+          <a:prstGeom prst="rect">
+            <a:avLst/>
+          </a:prstGeom>
+          <a:noFill/>
+        </p:spPr>
+        <p:txBody>
+          <a:bodyPr wrap="square" lIns="0" rIns="0" tIns="0" bIns="0">
+            <a:spAutoFit/>
+          </a:bodyPr>
+          <a:lstStyle/>
+          <a:p>
+            <a:pPr algn="l"/>
+            <a:r>
+              <a:rPr sz="3000" b="1">
+                <a:solidFill>
+                  <a:srgbClr val="FFFFFF"/>
+                </a:solidFill>
+                <a:latin typeface="Aptos Narrow"/>
+              </a:rPr>
+              <a:t>41,990</a:t>
+            </a:r>
+          </a:p>
+        </p:txBody>
+      </p:sp>
+      <p:sp>
+        <p:nvSpPr>
+          <p:cNvPr id="6" name="TextBox 5"/>
+          <p:cNvSpPr txBox="1"/>
+          <p:nvPr/>
+        </p:nvSpPr>
+        <p:spPr>
+          <a:xfrm>
+            <a:off x="822960" y="4754880"/>
+            <a:ext cx="2560320" cy="548640"/>
+          </a:xfrm>
+          <a:prstGeom prst="rect">
+            <a:avLst/>
+          </a:prstGeom>
+          <a:noFill/>
+        </p:spPr>
+        <p:txBody>
+          <a:bodyPr wrap="square" lIns="0" rIns="0" tIns="0" bIns="0">
+            <a:spAutoFit/>
+          </a:bodyPr>
+          <a:lstStyle/>
+          <a:p>
+            <a:pPr algn="l"/>
+            <a:r>
+              <a:rPr sz="1100" b="0">
+                <a:solidFill>
+                  <a:srgbClr val="C9C9C9"/>
+                </a:solidFill>
+                <a:latin typeface="Aptos Narrow"/>
+              </a:rPr>
+              <a:t>gross kill / quarter</a:t>
+            </a:r>
+          </a:p>
+        </p:txBody>
+      </p:sp>
+      <p:sp>
+        <p:nvSpPr>
+          <p:cNvPr id="7" name="TextBox 6"/>
+          <p:cNvSpPr txBox="1"/>
+          <p:nvPr/>
+        </p:nvSpPr>
+        <p:spPr>
+          <a:xfrm>
+            <a:off x="3520440" y="4160520"/>
+            <a:ext cx="2560320" cy="548640"/>
+          </a:xfrm>
+          <a:prstGeom prst="rect">
+            <a:avLst/>
+          </a:prstGeom>
+          <a:noFill/>
+        </p:spPr>
+        <p:txBody>
+          <a:bodyPr wrap="square" lIns="0" rIns="0" tIns="0" bIns="0">
+            <a:spAutoFit/>
+          </a:bodyPr>
+          <a:lstStyle/>
+          <a:p>
+            <a:pPr algn="l"/>
+            <a:r>
+              <a:rPr sz="3000" b="1">
+                <a:solidFill>
+                  <a:srgbClr val="FFFFFF"/>
+                </a:solidFill>
+                <a:latin typeface="Aptos Narrow"/>
+              </a:rPr>
+              <a:t>21,891</a:t>
+            </a:r>
+          </a:p>
+        </p:txBody>
+      </p:sp>
+      <p:sp>
+        <p:nvSpPr>
+          <p:cNvPr id="8" name="TextBox 7"/>
+          <p:cNvSpPr txBox="1"/>
+          <p:nvPr/>
+        </p:nvSpPr>
+        <p:spPr>
+          <a:xfrm>
+            <a:off x="3520440" y="4754880"/>
+            <a:ext cx="2560320" cy="548640"/>
+          </a:xfrm>
+          <a:prstGeom prst="rect">
+            <a:avLst/>
+          </a:prstGeom>
+          <a:noFill/>
+        </p:spPr>
+        <p:txBody>
+          <a:bodyPr wrap="square" lIns="0" rIns="0" tIns="0" bIns="0">
+            <a:spAutoFit/>
+          </a:bodyPr>
+          <a:lstStyle/>
+          <a:p>
+            <a:pPr algn="l"/>
+            <a:r>
+              <a:rPr sz="1100" b="0">
+                <a:solidFill>
+                  <a:srgbClr val="C9C9C9"/>
+                </a:solidFill>
+                <a:latin typeface="Aptos Narrow"/>
+              </a:rPr>
+              <a:t>net harvested / quarter</a:t>
+            </a:r>
+          </a:p>
+        </p:txBody>
+      </p:sp>
+      <p:sp>
+        <p:nvSpPr>
+          <p:cNvPr id="9" name="TextBox 8"/>
+          <p:cNvSpPr txBox="1"/>
+          <p:nvPr/>
+        </p:nvSpPr>
+        <p:spPr>
+          <a:xfrm>
+            <a:off x="6217920" y="4160520"/>
+            <a:ext cx="2560320" cy="548640"/>
+          </a:xfrm>
+          <a:prstGeom prst="rect">
+            <a:avLst/>
+          </a:prstGeom>
+          <a:noFill/>
+        </p:spPr>
+        <p:txBody>
+          <a:bodyPr wrap="square" lIns="0" rIns="0" tIns="0" bIns="0">
+            <a:spAutoFit/>
+          </a:bodyPr>
+          <a:lstStyle/>
+          <a:p>
+            <a:pPr algn="l"/>
+            <a:r>
+              <a:rPr sz="3000" b="1">
+                <a:solidFill>
+                  <a:srgbClr val="FFFFFF"/>
+                </a:solidFill>
+                <a:latin typeface="Aptos Narrow"/>
+              </a:rPr>
+              <a:t>8,434</a:t>
+            </a:r>
+          </a:p>
+        </p:txBody>
+      </p:sp>
+      <p:sp>
+        <p:nvSpPr>
+          <p:cNvPr id="10" name="TextBox 9"/>
+          <p:cNvSpPr txBox="1"/>
+          <p:nvPr/>
+        </p:nvSpPr>
+        <p:spPr>
+          <a:xfrm>
+            <a:off x="6217920" y="4754880"/>
+            <a:ext cx="2560320" cy="548640"/>
+          </a:xfrm>
+          <a:prstGeom prst="rect">
+            <a:avLst/>
+          </a:prstGeom>
+          <a:noFill/>
+        </p:spPr>
+        <p:txBody>
+          <a:bodyPr wrap="square" lIns="0" rIns="0" tIns="0" bIns="0">
+            <a:spAutoFit/>
+          </a:bodyPr>
+          <a:lstStyle/>
+          <a:p>
+            <a:pPr algn="l"/>
+            <a:r>
+              <a:rPr sz="1100" b="0">
+                <a:solidFill>
+                  <a:srgbClr val="C9C9C9"/>
+                </a:solidFill>
+                <a:latin typeface="Aptos Narrow"/>
+              </a:rPr>
+              <a:t>peak demand (Q4'27)</a:t>
+            </a:r>
+          </a:p>
+        </p:txBody>
+      </p:sp>
+      <p:sp>
+        <p:nvSpPr>
+          <p:cNvPr id="11" name="TextBox 10"/>
+          <p:cNvSpPr txBox="1"/>
+          <p:nvPr/>
+        </p:nvSpPr>
+        <p:spPr>
+          <a:xfrm>
+            <a:off x="8915400" y="4160520"/>
+            <a:ext cx="2560320" cy="548640"/>
+          </a:xfrm>
+          <a:prstGeom prst="rect">
+            <a:avLst/>
+          </a:prstGeom>
+          <a:noFill/>
+        </p:spPr>
+        <p:txBody>
+          <a:bodyPr wrap="square" lIns="0" rIns="0" tIns="0" bIns="0">
+            <a:spAutoFit/>
+          </a:bodyPr>
+          <a:lstStyle/>
+          <a:p>
+            <a:pPr algn="l"/>
+            <a:r>
+              <a:rPr sz="3000" b="1">
+                <a:solidFill>
+                  <a:srgbClr val="FFFFFF"/>
+                </a:solidFill>
+                <a:latin typeface="Aptos Narrow"/>
+              </a:rPr>
+              <a:t>2.6x</a:t>
+            </a:r>
+          </a:p>
+        </p:txBody>
+      </p:sp>
+      <p:sp>
+        <p:nvSpPr>
+          <p:cNvPr id="12" name="TextBox 11"/>
+          <p:cNvSpPr txBox="1"/>
+          <p:nvPr/>
+        </p:nvSpPr>
+        <p:spPr>
+          <a:xfrm>
+            <a:off x="8915400" y="4754880"/>
+            <a:ext cx="2560320" cy="548640"/>
+          </a:xfrm>
+          <a:prstGeom prst="rect">
+            <a:avLst/>
+          </a:prstGeom>
+          <a:noFill/>
+        </p:spPr>
+        <p:txBody>
+          <a:bodyPr wrap="square" lIns="0" rIns="0" tIns="0" bIns="0">
+            <a:spAutoFit/>
+          </a:bodyPr>
+          <a:lstStyle/>
+          <a:p>
+            <a:pPr algn="l"/>
+            <a:r>
+              <a:rPr sz="1100" b="0">
+                <a:solidFill>
+                  <a:srgbClr val="C9C9C9"/>
+                </a:solidFill>
+                <a:latin typeface="Aptos Narrow"/>
+              </a:rPr>
+              <a:t>coverage at peak</a:t>
+            </a:r>
+          </a:p>
+        </p:txBody>
+      </p:sp>
     </p:spTree>
   </p:cSld>
   <p:clrMapOvr>
@@ -7793,17 +6986,87 @@
         <p:nvPr/>
       </p:nvGrpSpPr>
       <p:grpSpPr/>
+      <p:sp>
+        <p:nvSpPr>
+          <p:cNvPr id="2" name="TextBox 1"/>
+          <p:cNvSpPr txBox="1"/>
+          <p:nvPr/>
+        </p:nvSpPr>
+        <p:spPr>
+          <a:xfrm>
+            <a:off x="502920" y="292608"/>
+            <a:ext cx="11155680" cy="548640"/>
+          </a:xfrm>
+          <a:prstGeom prst="rect">
+            <a:avLst/>
+          </a:prstGeom>
+          <a:noFill/>
+        </p:spPr>
+        <p:txBody>
+          <a:bodyPr wrap="square" lIns="0" rIns="0" tIns="0" bIns="0">
+            <a:spAutoFit/>
+          </a:bodyPr>
+          <a:lstStyle/>
+          <a:p>
+            <a:pPr algn="l"/>
+            <a:r>
+              <a:rPr sz="2600" b="1">
+                <a:solidFill>
+                  <a:srgbClr val="0B0B0B"/>
+                </a:solidFill>
+                <a:latin typeface="Aptos Narrow"/>
+              </a:rPr>
+              <a:t>Net supply at spec yield vs demand</a:t>
+            </a:r>
+          </a:p>
+        </p:txBody>
+      </p:sp>
+      <p:sp>
+        <p:nvSpPr>
+          <p:cNvPr id="3" name="TextBox 2"/>
+          <p:cNvSpPr txBox="1"/>
+          <p:nvPr/>
+        </p:nvSpPr>
+        <p:spPr>
+          <a:xfrm>
+            <a:off x="502920" y="841248"/>
+            <a:ext cx="11155680" cy="365760"/>
+          </a:xfrm>
+          <a:prstGeom prst="rect">
+            <a:avLst/>
+          </a:prstGeom>
+          <a:noFill/>
+        </p:spPr>
+        <p:txBody>
+          <a:bodyPr wrap="square" lIns="0" rIns="0" tIns="0" bIns="0">
+            <a:spAutoFit/>
+          </a:bodyPr>
+          <a:lstStyle/>
+          <a:p>
+            <a:pPr algn="l"/>
+            <a:r>
+              <a:rPr sz="1300" b="0">
+                <a:solidFill>
+                  <a:srgbClr val="595959"/>
+                </a:solidFill>
+                <a:latin typeface="Aptos Narrow"/>
+              </a:rPr>
+              <a:t>Spec-passed supply of 31,733 pigs per quarter covers peak demand about 3.8x — the gray band marks the 41,990 gross kill.</a:t>
+            </a:r>
+          </a:p>
+        </p:txBody>
+      </p:sp>
       <p:graphicFrame>
         <p:nvGraphicFramePr>
-          <p:cNvPr id="2" name="Chart 1"/>
+          <p:cNvPr id="4" name="Chart 3"/>
           <p:cNvGraphicFramePr>
             <a:graphicFrameLocks noGrp="1"/>
           </p:cNvGraphicFramePr>
           <p:nvPr/>
         </p:nvGraphicFramePr>
         <p:xfrm>
-          <a:off x="365760" y="228600"/>
-          <a:ext cx="11457432" cy="6400800"/>
+          <a:off x="384048" y="1298448"/>
+          <a:ext cx="11430000" cy="5394960"/>
         </p:xfrm>
         <a:graphic>
           <a:graphicData uri="http://schemas.openxmlformats.org/drawingml/2006/chart">
@@ -7829,17 +7092,87 @@
         <p:nvPr/>
       </p:nvGrpSpPr>
       <p:grpSpPr/>
+      <p:sp>
+        <p:nvSpPr>
+          <p:cNvPr id="2" name="TextBox 1"/>
+          <p:cNvSpPr txBox="1"/>
+          <p:nvPr/>
+        </p:nvSpPr>
+        <p:spPr>
+          <a:xfrm>
+            <a:off x="502920" y="292608"/>
+            <a:ext cx="11155680" cy="548640"/>
+          </a:xfrm>
+          <a:prstGeom prst="rect">
+            <a:avLst/>
+          </a:prstGeom>
+          <a:noFill/>
+        </p:spPr>
+        <p:txBody>
+          <a:bodyPr wrap="square" lIns="0" rIns="0" tIns="0" bIns="0">
+            <a:spAutoFit/>
+          </a:bodyPr>
+          <a:lstStyle/>
+          <a:p>
+            <a:pPr algn="l"/>
+            <a:r>
+              <a:rPr sz="2600" b="1">
+                <a:solidFill>
+                  <a:srgbClr val="0B0B0B"/>
+                </a:solidFill>
+                <a:latin typeface="Aptos Narrow"/>
+              </a:rPr>
+              <a:t>Net harvested supply vs demand</a:t>
+            </a:r>
+          </a:p>
+        </p:txBody>
+      </p:sp>
+      <p:sp>
+        <p:nvSpPr>
+          <p:cNvPr id="3" name="TextBox 2"/>
+          <p:cNvSpPr txBox="1"/>
+          <p:nvPr/>
+        </p:nvSpPr>
+        <p:spPr>
+          <a:xfrm>
+            <a:off x="502920" y="841248"/>
+            <a:ext cx="11155680" cy="365760"/>
+          </a:xfrm>
+          <a:prstGeom prst="rect">
+            <a:avLst/>
+          </a:prstGeom>
+          <a:noFill/>
+        </p:spPr>
+        <p:txBody>
+          <a:bodyPr wrap="square" lIns="0" rIns="0" tIns="0" bIns="0">
+            <a:spAutoFit/>
+          </a:bodyPr>
+          <a:lstStyle/>
+          <a:p>
+            <a:pPr algn="l"/>
+            <a:r>
+              <a:rPr sz="1300" b="0">
+                <a:solidFill>
+                  <a:srgbClr val="595959"/>
+                </a:solidFill>
+                <a:latin typeface="Aptos Narrow"/>
+              </a:rPr>
+              <a:t>After harvest yield, 21,891 pigs per quarter still cover peak demand 2.6x — gray bands mark spec-passed (31,733) and gross kill (41,990).</a:t>
+            </a:r>
+          </a:p>
+        </p:txBody>
+      </p:sp>
       <p:graphicFrame>
         <p:nvGraphicFramePr>
-          <p:cNvPr id="2" name="Chart 1"/>
+          <p:cNvPr id="4" name="Chart 3"/>
           <p:cNvGraphicFramePr>
             <a:graphicFrameLocks noGrp="1"/>
           </p:cNvGraphicFramePr>
           <p:nvPr/>
         </p:nvGraphicFramePr>
         <p:xfrm>
-          <a:off x="365760" y="228600"/>
-          <a:ext cx="11457432" cy="6400800"/>
+          <a:off x="384048" y="1298448"/>
+          <a:ext cx="11430000" cy="5394960"/>
         </p:xfrm>
         <a:graphic>
           <a:graphicData uri="http://schemas.openxmlformats.org/drawingml/2006/chart">
@@ -7865,17 +7198,87 @@
         <p:nvPr/>
       </p:nvGrpSpPr>
       <p:grpSpPr/>
+      <p:sp>
+        <p:nvSpPr>
+          <p:cNvPr id="2" name="TextBox 1"/>
+          <p:cNvSpPr txBox="1"/>
+          <p:nvPr/>
+        </p:nvSpPr>
+        <p:spPr>
+          <a:xfrm>
+            <a:off x="502920" y="292608"/>
+            <a:ext cx="11155680" cy="548640"/>
+          </a:xfrm>
+          <a:prstGeom prst="rect">
+            <a:avLst/>
+          </a:prstGeom>
+          <a:noFill/>
+        </p:spPr>
+        <p:txBody>
+          <a:bodyPr wrap="square" lIns="0" rIns="0" tIns="0" bIns="0">
+            <a:spAutoFit/>
+          </a:bodyPr>
+          <a:lstStyle/>
+          <a:p>
+            <a:pPr algn="l"/>
+            <a:r>
+              <a:rPr sz="2600" b="1">
+                <a:solidFill>
+                  <a:srgbClr val="0B0B0B"/>
+                </a:solidFill>
+                <a:latin typeface="Aptos Narrow"/>
+              </a:rPr>
+              <a:t>Demand vs net harvested capacity (detail)</a:t>
+            </a:r>
+          </a:p>
+        </p:txBody>
+      </p:sp>
+      <p:sp>
+        <p:nvSpPr>
+          <p:cNvPr id="3" name="TextBox 2"/>
+          <p:cNvSpPr txBox="1"/>
+          <p:nvPr/>
+        </p:nvSpPr>
+        <p:spPr>
+          <a:xfrm>
+            <a:off x="502920" y="841248"/>
+            <a:ext cx="11155680" cy="365760"/>
+          </a:xfrm>
+          <a:prstGeom prst="rect">
+            <a:avLst/>
+          </a:prstGeom>
+          <a:noFill/>
+        </p:spPr>
+        <p:txBody>
+          <a:bodyPr wrap="square" lIns="0" rIns="0" tIns="0" bIns="0">
+            <a:spAutoFit/>
+          </a:bodyPr>
+          <a:lstStyle/>
+          <a:p>
+            <a:pPr algn="l"/>
+            <a:r>
+              <a:rPr sz="1300" b="0">
+                <a:solidFill>
+                  <a:srgbClr val="595959"/>
+                </a:solidFill>
+                <a:latin typeface="Aptos Narrow"/>
+              </a:rPr>
+              <a:t>Demand rises 7,305 to 8,434 while net harvested capacity holds at 21,891 — a 2.6x cushion at peak.</a:t>
+            </a:r>
+          </a:p>
+        </p:txBody>
+      </p:sp>
       <p:graphicFrame>
         <p:nvGraphicFramePr>
-          <p:cNvPr id="2" name="Chart 1"/>
+          <p:cNvPr id="4" name="Chart 3"/>
           <p:cNvGraphicFramePr>
             <a:graphicFrameLocks noGrp="1"/>
           </p:cNvGraphicFramePr>
           <p:nvPr/>
         </p:nvGraphicFramePr>
         <p:xfrm>
-          <a:off x="365760" y="228600"/>
-          <a:ext cx="11457432" cy="6400800"/>
+          <a:off x="384048" y="1298448"/>
+          <a:ext cx="11430000" cy="5394960"/>
         </p:xfrm>
         <a:graphic>
           <a:graphicData uri="http://schemas.openxmlformats.org/drawingml/2006/chart">
@@ -7901,17 +7304,87 @@
         <p:nvPr/>
       </p:nvGrpSpPr>
       <p:grpSpPr/>
+      <p:sp>
+        <p:nvSpPr>
+          <p:cNvPr id="2" name="TextBox 1"/>
+          <p:cNvSpPr txBox="1"/>
+          <p:nvPr/>
+        </p:nvSpPr>
+        <p:spPr>
+          <a:xfrm>
+            <a:off x="502920" y="292608"/>
+            <a:ext cx="11155680" cy="548640"/>
+          </a:xfrm>
+          <a:prstGeom prst="rect">
+            <a:avLst/>
+          </a:prstGeom>
+          <a:noFill/>
+        </p:spPr>
+        <p:txBody>
+          <a:bodyPr wrap="square" lIns="0" rIns="0" tIns="0" bIns="0">
+            <a:spAutoFit/>
+          </a:bodyPr>
+          <a:lstStyle/>
+          <a:p>
+            <a:pPr algn="l"/>
+            <a:r>
+              <a:rPr sz="2600" b="1">
+                <a:solidFill>
+                  <a:srgbClr val="0B0B0B"/>
+                </a:solidFill>
+                <a:latin typeface="Aptos Narrow"/>
+              </a:rPr>
+              <a:t>Capacity funnel: gross kill to net harvested</a:t>
+            </a:r>
+          </a:p>
+        </p:txBody>
+      </p:sp>
+      <p:sp>
+        <p:nvSpPr>
+          <p:cNvPr id="3" name="TextBox 2"/>
+          <p:cNvSpPr txBox="1"/>
+          <p:nvPr/>
+        </p:nvSpPr>
+        <p:spPr>
+          <a:xfrm>
+            <a:off x="502920" y="841248"/>
+            <a:ext cx="11155680" cy="365760"/>
+          </a:xfrm>
+          <a:prstGeom prst="rect">
+            <a:avLst/>
+          </a:prstGeom>
+          <a:noFill/>
+        </p:spPr>
+        <p:txBody>
+          <a:bodyPr wrap="square" lIns="0" rIns="0" tIns="0" bIns="0">
+            <a:spAutoFit/>
+          </a:bodyPr>
+          <a:lstStyle/>
+          <a:p>
+            <a:pPr algn="l"/>
+            <a:r>
+              <a:rPr sz="1300" b="0">
+                <a:solidFill>
+                  <a:srgbClr val="595959"/>
+                </a:solidFill>
+                <a:latin typeface="Aptos Narrow"/>
+              </a:rPr>
+              <a:t>Each yield step shrinks supply: 41,990 gross, 31,733 after spec (-24%), 21,891 after harvest (-31%), against 8,434 peak demand.</a:t>
+            </a:r>
+          </a:p>
+        </p:txBody>
+      </p:sp>
       <p:graphicFrame>
         <p:nvGraphicFramePr>
-          <p:cNvPr id="2" name="Chart 1"/>
+          <p:cNvPr id="4" name="Chart 3"/>
           <p:cNvGraphicFramePr>
             <a:graphicFrameLocks noGrp="1"/>
           </p:cNvGraphicFramePr>
           <p:nvPr/>
         </p:nvGraphicFramePr>
         <p:xfrm>
-          <a:off x="365760" y="228600"/>
-          <a:ext cx="11457432" cy="6400800"/>
+          <a:off x="384048" y="1298448"/>
+          <a:ext cx="11430000" cy="5394960"/>
         </p:xfrm>
         <a:graphic>
           <a:graphicData uri="http://schemas.openxmlformats.org/drawingml/2006/chart">
@@ -7937,17 +7410,87 @@
         <p:nvPr/>
       </p:nvGrpSpPr>
       <p:grpSpPr/>
+      <p:sp>
+        <p:nvSpPr>
+          <p:cNvPr id="2" name="TextBox 1"/>
+          <p:cNvSpPr txBox="1"/>
+          <p:nvPr/>
+        </p:nvSpPr>
+        <p:spPr>
+          <a:xfrm>
+            <a:off x="502920" y="292608"/>
+            <a:ext cx="11155680" cy="548640"/>
+          </a:xfrm>
+          <a:prstGeom prst="rect">
+            <a:avLst/>
+          </a:prstGeom>
+          <a:noFill/>
+        </p:spPr>
+        <p:txBody>
+          <a:bodyPr wrap="square" lIns="0" rIns="0" tIns="0" bIns="0">
+            <a:spAutoFit/>
+          </a:bodyPr>
+          <a:lstStyle/>
+          <a:p>
+            <a:pPr algn="l"/>
+            <a:r>
+              <a:rPr sz="2600" b="1">
+                <a:solidFill>
+                  <a:srgbClr val="0B0B0B"/>
+                </a:solidFill>
+                <a:latin typeface="Aptos Narrow"/>
+              </a:rPr>
+              <a:t>Tissue demand by part vs capacity</a:t>
+            </a:r>
+          </a:p>
+        </p:txBody>
+      </p:sp>
+      <p:sp>
+        <p:nvSpPr>
+          <p:cNvPr id="3" name="TextBox 2"/>
+          <p:cNvSpPr txBox="1"/>
+          <p:nvPr/>
+        </p:nvSpPr>
+        <p:spPr>
+          <a:xfrm>
+            <a:off x="502920" y="841248"/>
+            <a:ext cx="11155680" cy="365760"/>
+          </a:xfrm>
+          <a:prstGeom prst="rect">
+            <a:avLst/>
+          </a:prstGeom>
+          <a:noFill/>
+        </p:spPr>
+        <p:txBody>
+          <a:bodyPr wrap="square" lIns="0" rIns="0" tIns="0" bIns="0">
+            <a:spAutoFit/>
+          </a:bodyPr>
+          <a:lstStyle/>
+          <a:p>
+            <a:pPr algn="l"/>
+            <a:r>
+              <a:rPr sz="1300" b="0">
+                <a:solidFill>
+                  <a:srgbClr val="595959"/>
+                </a:solidFill>
+                <a:latin typeface="Aptos Narrow"/>
+              </a:rPr>
+              <a:t>Demand mix by tissue part number — every quarter's total sits far below the 21,891-pig net capacity line.</a:t>
+            </a:r>
+          </a:p>
+        </p:txBody>
+      </p:sp>
       <p:graphicFrame>
         <p:nvGraphicFramePr>
-          <p:cNvPr id="2" name="Chart 1"/>
+          <p:cNvPr id="4" name="Chart 3"/>
           <p:cNvGraphicFramePr>
             <a:graphicFrameLocks noGrp="1"/>
           </p:cNvGraphicFramePr>
           <p:nvPr/>
         </p:nvGraphicFramePr>
         <p:xfrm>
-          <a:off x="365760" y="228600"/>
-          <a:ext cx="11457432" cy="6400800"/>
+          <a:off x="384048" y="1298448"/>
+          <a:ext cx="11430000" cy="5394960"/>
         </p:xfrm>
         <a:graphic>
           <a:graphicData uri="http://schemas.openxmlformats.org/drawingml/2006/chart">

</xml_diff>

<commit_message>
Fix number formatting in deck charts and lead with the funnel
PowerPoint treats numFmt without sourceLinked=0 as source-linked and fell
back to raw cached floats (21890.54061); every numFmt is now pinned,
caches are rounded to integers with a #,##0 cache format, and per-point
labels get explicit text properties so they keep their intended colors.
All value axes now use comma-separated integers. Slides reordered to open
with the capacity funnel, then harvested vs demand.

Co-Authored-By: Claude Fable 5 <noreply@anthropic.com>
Claude-Session: https://claude.ai/code/session_014fnah7533XZizagq8i6MTs
</commit_message>
<xml_diff>
--- a/PVA second supplier initiative/Supplier_Capacity_Charts.pptx
+++ b/PVA second supplier initiative/Supplier_Capacity_Charts.pptx
@@ -137,77 +137,6 @@
           <idx val="0"/>
           <order val="0"/>
           <tx>
-            <v>Gross kill</v>
-          </tx>
-          <spPr>
-            <a:solidFill>
-              <a:srgbClr val="D9D9D9"/>
-            </a:solidFill>
-            <a:ln>
-              <a:noFill/>
-              <a:prstDash val="solid"/>
-            </a:ln>
-          </spPr>
-          <cat>
-            <strRef>
-              <f>'Chart Data'!$B$4:$F$4</f>
-              <strCache>
-                <ptCount val="5"/>
-                <pt idx="0">
-                  <v>Q4'26</v>
-                </pt>
-                <pt idx="1">
-                  <v>Q1'27</v>
-                </pt>
-                <pt idx="2">
-                  <v>Q2'27</v>
-                </pt>
-                <pt idx="3">
-                  <v>Q3'27</v>
-                </pt>
-                <pt idx="4">
-                  <v>Q4'27</v>
-                </pt>
-              </strCache>
-            </strRef>
-          </cat>
-          <val>
-            <numRef>
-              <f>'Chart Data'!$B$15:$F$15</f>
-              <numCache>
-                <formatCode>General</formatCode>
-                <ptCount val="5"/>
-                <pt idx="0">
-                  <v>41990</v>
-                </pt>
-                <pt idx="1">
-                  <v>41990</v>
-                </pt>
-                <pt idx="2">
-                  <v>41990</v>
-                </pt>
-                <pt idx="3">
-                  <v>41990</v>
-                </pt>
-                <pt idx="4">
-                  <v>41990</v>
-                </pt>
-              </numCache>
-            </numRef>
-          </val>
-        </ser>
-        <gapWidth val="50"/>
-        <overlap val="100"/>
-        <axId val="10"/>
-        <axId val="100"/>
-      </barChart>
-      <barChart>
-        <barDir val="col"/>
-        <grouping val="stacked"/>
-        <ser>
-          <idx val="1"/>
-          <order val="1"/>
-          <tx>
             <strRef>
               <f>Sheet1!$D$16</f>
               <strCache>
@@ -229,19 +158,280 @@
               <a:prstDash val="solid"/>
             </a:ln>
           </spPr>
+          <cat>
+            <strRef>
+              <f>'Chart Data'!$I$4:$L$4</f>
+              <strCache>
+                <ptCount val="4"/>
+                <pt idx="0">
+                  <v>Gross kill
+41,990</v>
+                </pt>
+                <pt idx="1">
+                  <v>After spec yield
+31,733  (-24%)</v>
+                </pt>
+                <pt idx="2">
+                  <v>After harvest yield
+21,891  (-31%)</v>
+                </pt>
+                <pt idx="3">
+                  <v>Peak demand Q4'27
+8,434</v>
+                </pt>
+              </strCache>
+            </strRef>
+          </cat>
+          <val>
+            <numRef>
+              <f>'Chart Data'!$I$5:$L$5</f>
+              <numCache>
+                <formatCode>#,##0</formatCode>
+                <ptCount val="4"/>
+                <pt idx="0">
+                  <v>32500</v>
+                </pt>
+                <pt idx="1">
+                  <v>24964</v>
+                </pt>
+                <pt idx="2">
+                  <v>17221</v>
+                </pt>
+              </numCache>
+            </numRef>
+          </val>
+        </ser>
+        <ser>
+          <idx val="1"/>
+          <order val="1"/>
+          <tx>
+            <strRef>
+              <f>Sheet1!$D$17</f>
+              <strCache>
+                <ptCount val="1"/>
+                <pt idx="0">
+                  <v>Nahunta</v>
+                </pt>
+              </strCache>
+            </strRef>
+          </tx>
+          <spPr>
+            <a:solidFill>
+              <a:srgbClr val="EB6834"/>
+            </a:solidFill>
+            <a:ln w="15875">
+              <a:solidFill>
+                <a:srgbClr val="FFFFFF"/>
+              </a:solidFill>
+              <a:prstDash val="solid"/>
+            </a:ln>
+          </spPr>
+          <cat>
+            <strRef>
+              <f>'Chart Data'!$I$4:$L$4</f>
+              <strCache>
+                <ptCount val="4"/>
+                <pt idx="0">
+                  <v>Gross kill
+41,990</v>
+                </pt>
+                <pt idx="1">
+                  <v>After spec yield
+31,733  (-24%)</v>
+                </pt>
+                <pt idx="2">
+                  <v>After harvest yield
+21,891  (-31%)</v>
+                </pt>
+                <pt idx="3">
+                  <v>Peak demand Q4'27
+8,434</v>
+                </pt>
+              </strCache>
+            </strRef>
+          </cat>
+          <val>
+            <numRef>
+              <f>'Chart Data'!$I$6:$L$6</f>
+              <numCache>
+                <formatCode>#,##0</formatCode>
+                <ptCount val="4"/>
+                <pt idx="0">
+                  <v>2340</v>
+                </pt>
+                <pt idx="1">
+                  <v>1797</v>
+                </pt>
+                <pt idx="2">
+                  <v>1240</v>
+                </pt>
+              </numCache>
+            </numRef>
+          </val>
+        </ser>
+        <ser>
+          <idx val="2"/>
+          <order val="2"/>
+          <tx>
+            <strRef>
+              <f>Sheet1!$D$18</f>
+              <strCache>
+                <ptCount val="1"/>
+                <pt idx="0">
+                  <v>Customs</v>
+                </pt>
+              </strCache>
+            </strRef>
+          </tx>
+          <spPr>
+            <a:solidFill>
+              <a:srgbClr val="1BAF7A"/>
+            </a:solidFill>
+            <a:ln w="15875">
+              <a:solidFill>
+                <a:srgbClr val="FFFFFF"/>
+              </a:solidFill>
+              <a:prstDash val="solid"/>
+            </a:ln>
+          </spPr>
+          <cat>
+            <strRef>
+              <f>'Chart Data'!$I$4:$L$4</f>
+              <strCache>
+                <ptCount val="4"/>
+                <pt idx="0">
+                  <v>Gross kill
+41,990</v>
+                </pt>
+                <pt idx="1">
+                  <v>After spec yield
+31,733  (-24%)</v>
+                </pt>
+                <pt idx="2">
+                  <v>After harvest yield
+21,891  (-31%)</v>
+                </pt>
+                <pt idx="3">
+                  <v>Peak demand Q4'27
+8,434</v>
+                </pt>
+              </strCache>
+            </strRef>
+          </cat>
+          <val>
+            <numRef>
+              <f>'Chart Data'!$I$7:$L$7</f>
+              <numCache>
+                <formatCode>#,##0</formatCode>
+                <ptCount val="4"/>
+                <pt idx="0">
+                  <v>1950</v>
+                </pt>
+                <pt idx="1">
+                  <v>1498</v>
+                </pt>
+                <pt idx="2">
+                  <v>1033</v>
+                </pt>
+              </numCache>
+            </numRef>
+          </val>
+        </ser>
+        <ser>
+          <idx val="3"/>
+          <order val="3"/>
+          <tx>
+            <strRef>
+              <f>Sheet1!$D$19</f>
+              <strCache>
+                <ptCount val="1"/>
+                <pt idx="0">
+                  <v>Parks</v>
+                </pt>
+              </strCache>
+            </strRef>
+          </tx>
+          <spPr>
+            <a:solidFill>
+              <a:srgbClr val="EDA100"/>
+            </a:solidFill>
+            <a:ln w="15875">
+              <a:solidFill>
+                <a:srgbClr val="FFFFFF"/>
+              </a:solidFill>
+              <a:prstDash val="solid"/>
+            </a:ln>
+          </spPr>
+          <cat>
+            <strRef>
+              <f>'Chart Data'!$I$4:$L$4</f>
+              <strCache>
+                <ptCount val="4"/>
+                <pt idx="0">
+                  <v>Gross kill
+41,990</v>
+                </pt>
+                <pt idx="1">
+                  <v>After spec yield
+31,733  (-24%)</v>
+                </pt>
+                <pt idx="2">
+                  <v>After harvest yield
+21,891  (-31%)</v>
+                </pt>
+                <pt idx="3">
+                  <v>Peak demand Q4'27
+8,434</v>
+                </pt>
+              </strCache>
+            </strRef>
+          </cat>
+          <val>
+            <numRef>
+              <f>'Chart Data'!$I$8:$L$8</f>
+              <numCache>
+                <formatCode>#,##0</formatCode>
+                <ptCount val="4"/>
+                <pt idx="0">
+                  <v>5200</v>
+                </pt>
+                <pt idx="1">
+                  <v>3474</v>
+                </pt>
+                <pt idx="2">
+                  <v>2397</v>
+                </pt>
+              </numCache>
+            </numRef>
+          </val>
+        </ser>
+        <ser>
+          <idx val="4"/>
+          <order val="4"/>
+          <tx>
+            <strRef>
+              <f>'Chart Data'!$H$9</f>
+              <strCache>
+                <ptCount val="1"/>
+                <pt idx="0">
+                  <v>Tissue demand</v>
+                </pt>
+              </strCache>
+            </strRef>
+          </tx>
+          <spPr>
+            <a:solidFill>
+              <a:srgbClr val="0B0B0B"/>
+            </a:solidFill>
+            <a:ln w="15875">
+              <a:solidFill>
+                <a:srgbClr val="FFFFFF"/>
+              </a:solidFill>
+              <a:prstDash val="solid"/>
+            </a:ln>
+          </spPr>
           <dLbls>
-            <dLbl>
-              <idx val="0"/>
-              <numFmt formatCode="#,##0"/>
-              <dLblPos val="ctr"/>
-              <showLegendKey val="0"/>
-              <showVal val="1"/>
-              <showCatName val="0"/>
-              <showSerName val="0"/>
-              <showPercent val="0"/>
-              <showBubbleSize val="0"/>
-            </dLbl>
-            <numFmt formatCode="#,##0"/>
+            <numFmt formatCode="#,##0" sourceLinked="0"/>
             <txPr>
               <a:bodyPr/>
               <a:p>
@@ -264,372 +454,7 @@
                 </a:endParaRPr>
               </a:p>
             </txPr>
-            <showLegendKey val="0"/>
-            <showVal val="0"/>
-            <showCatName val="0"/>
-            <showSerName val="0"/>
-            <showPercent val="0"/>
-            <showBubbleSize val="0"/>
-          </dLbls>
-          <val>
-            <numRef>
-              <f>'Chart Data'!$B$5:$F$5</f>
-              <numCache>
-                <formatCode>General</formatCode>
-                <ptCount val="5"/>
-                <pt idx="0">
-                  <v>24963.6036960986</v>
-                </pt>
-                <pt idx="1">
-                  <v>24963.6036960986</v>
-                </pt>
-                <pt idx="2">
-                  <v>24963.6036960986</v>
-                </pt>
-                <pt idx="3">
-                  <v>24963.6036960986</v>
-                </pt>
-                <pt idx="4">
-                  <v>24963.6036960986</v>
-                </pt>
-              </numCache>
-            </numRef>
-          </val>
-        </ser>
-        <ser>
-          <idx val="2"/>
-          <order val="2"/>
-          <tx>
-            <strRef>
-              <f>Sheet1!$D$17</f>
-              <strCache>
-                <ptCount val="1"/>
-                <pt idx="0">
-                  <v>Nahunta</v>
-                </pt>
-              </strCache>
-            </strRef>
-          </tx>
-          <spPr>
-            <a:solidFill>
-              <a:srgbClr val="EB6834"/>
-            </a:solidFill>
-            <a:ln w="15875">
-              <a:solidFill>
-                <a:srgbClr val="FFFFFF"/>
-              </a:solidFill>
-              <a:prstDash val="solid"/>
-            </a:ln>
-          </spPr>
-          <val>
-            <numRef>
-              <f>'Chart Data'!$B$6:$F$6</f>
-              <numCache>
-                <formatCode>General</formatCode>
-                <ptCount val="5"/>
-                <pt idx="0">
-                  <v>1797.3794661191</v>
-                </pt>
-                <pt idx="1">
-                  <v>1797.3794661191</v>
-                </pt>
-                <pt idx="2">
-                  <v>1797.3794661191</v>
-                </pt>
-                <pt idx="3">
-                  <v>1797.3794661191</v>
-                </pt>
-                <pt idx="4">
-                  <v>1797.3794661191</v>
-                </pt>
-              </numCache>
-            </numRef>
-          </val>
-        </ser>
-        <ser>
-          <idx val="3"/>
-          <order val="3"/>
-          <tx>
-            <strRef>
-              <f>Sheet1!$D$18</f>
-              <strCache>
-                <ptCount val="1"/>
-                <pt idx="0">
-                  <v>Customs</v>
-                </pt>
-              </strCache>
-            </strRef>
-          </tx>
-          <spPr>
-            <a:solidFill>
-              <a:srgbClr val="1BAF7A"/>
-            </a:solidFill>
-            <a:ln w="15875">
-              <a:solidFill>
-                <a:srgbClr val="FFFFFF"/>
-              </a:solidFill>
-              <a:prstDash val="solid"/>
-            </a:ln>
-          </spPr>
-          <val>
-            <numRef>
-              <f>'Chart Data'!$B$7:$F$7</f>
-              <numCache>
-                <formatCode>General</formatCode>
-                <ptCount val="5"/>
-                <pt idx="0">
-                  <v>1497.81622176591</v>
-                </pt>
-                <pt idx="1">
-                  <v>1497.81622176591</v>
-                </pt>
-                <pt idx="2">
-                  <v>1497.81622176591</v>
-                </pt>
-                <pt idx="3">
-                  <v>1497.81622176591</v>
-                </pt>
-                <pt idx="4">
-                  <v>1497.81622176591</v>
-                </pt>
-              </numCache>
-            </numRef>
-          </val>
-        </ser>
-        <ser>
-          <idx val="4"/>
-          <order val="4"/>
-          <tx>
-            <strRef>
-              <f>Sheet1!$D$19</f>
-              <strCache>
-                <ptCount val="1"/>
-                <pt idx="0">
-                  <v>Parks</v>
-                </pt>
-              </strCache>
-            </strRef>
-          </tx>
-          <spPr>
-            <a:solidFill>
-              <a:srgbClr val="EDA100"/>
-            </a:solidFill>
-            <a:ln w="15875">
-              <a:solidFill>
-                <a:srgbClr val="FFFFFF"/>
-              </a:solidFill>
-              <a:prstDash val="solid"/>
-            </a:ln>
-          </spPr>
-          <dLbls>
-            <dLbl>
-              <idx val="0"/>
-              <numFmt formatCode="#,##0"/>
-              <dLblPos val="ctr"/>
-              <showLegendKey val="0"/>
-              <showVal val="1"/>
-              <showCatName val="0"/>
-              <showSerName val="0"/>
-              <showPercent val="0"/>
-              <showBubbleSize val="0"/>
-            </dLbl>
-            <numFmt formatCode="#,##0"/>
-            <txPr>
-              <a:bodyPr/>
-              <a:p>
-                <a:pPr>
-                  <a:defRPr sz="1150" b="1" i="0">
-                    <a:solidFill>
-                      <a:srgbClr val="0B0B0B"/>
-                    </a:solidFill>
-                    <a:latin typeface="Aptos Narrow"/>
-                  </a:defRPr>
-                </a:pPr>
-                <a:r>
-                  <a:t/>
-                </a:r>
-                <a:endParaRPr sz="1150" b="1" i="0">
-                  <a:solidFill>
-                    <a:srgbClr val="0B0B0B"/>
-                  </a:solidFill>
-                  <a:latin typeface="Aptos Narrow"/>
-                </a:endParaRPr>
-              </a:p>
-            </txPr>
-            <showLegendKey val="0"/>
-            <showVal val="0"/>
-            <showCatName val="0"/>
-            <showSerName val="0"/>
-            <showPercent val="0"/>
-            <showBubbleSize val="0"/>
-          </dLbls>
-          <val>
-            <numRef>
-              <f>'Chart Data'!$B$8:$F$8</f>
-              <numCache>
-                <formatCode>General</formatCode>
-                <ptCount val="5"/>
-                <pt idx="0">
-                  <v>3474.17659137577</v>
-                </pt>
-                <pt idx="1">
-                  <v>3474.17659137577</v>
-                </pt>
-                <pt idx="2">
-                  <v>3474.17659137577</v>
-                </pt>
-                <pt idx="3">
-                  <v>3474.17659137577</v>
-                </pt>
-                <pt idx="4">
-                  <v>3474.17659137577</v>
-                </pt>
-              </numCache>
-            </numRef>
-          </val>
-        </ser>
-        <gapWidth val="200"/>
-        <overlap val="100"/>
-        <axId val="10"/>
-        <axId val="200"/>
-      </barChart>
-      <lineChart>
-        <grouping val="standard"/>
-        <ser>
-          <idx val="5"/>
-          <order val="5"/>
-          <tx>
-            <v>Demand</v>
-          </tx>
-          <spPr>
-            <a:ln w="19050" cap="rnd">
-              <a:solidFill>
-                <a:srgbClr val="0B0B0B"/>
-              </a:solidFill>
-              <a:prstDash val="solid"/>
-            </a:ln>
-          </spPr>
-          <marker>
-            <symbol val="none"/>
-            <spPr>
-              <a:ln>
-                <a:prstDash val="solid"/>
-              </a:ln>
-            </spPr>
-          </marker>
-          <dLbls>
-            <dLbl>
-              <idx val="4"/>
-              <numFmt formatCode="#,##0"/>
-              <dLblPos val="t"/>
-              <showLegendKey val="0"/>
-              <showVal val="1"/>
-              <showCatName val="0"/>
-              <showSerName val="0"/>
-              <showPercent val="0"/>
-              <showBubbleSize val="0"/>
-            </dLbl>
-            <numFmt formatCode="#,##0"/>
-            <txPr>
-              <a:bodyPr/>
-              <a:p>
-                <a:pPr>
-                  <a:defRPr sz="1150" b="1" i="0">
-                    <a:solidFill>
-                      <a:srgbClr val="FFFFFF"/>
-                    </a:solidFill>
-                    <a:latin typeface="Aptos Narrow"/>
-                  </a:defRPr>
-                </a:pPr>
-                <a:r>
-                  <a:t/>
-                </a:r>
-                <a:endParaRPr sz="1150" b="1" i="0">
-                  <a:solidFill>
-                    <a:srgbClr val="FFFFFF"/>
-                  </a:solidFill>
-                  <a:latin typeface="Aptos Narrow"/>
-                </a:endParaRPr>
-              </a:p>
-            </txPr>
-            <showLegendKey val="0"/>
-            <showVal val="0"/>
-            <showCatName val="0"/>
-            <showSerName val="0"/>
-            <showPercent val="0"/>
-            <showBubbleSize val="0"/>
-          </dLbls>
-          <val>
-            <numRef>
-              <f>'Chart Data'!$B$21:$F$21</f>
-              <numCache>
-                <formatCode>General</formatCode>
-                <ptCount val="5"/>
-                <pt idx="0">
-                  <v>7305</v>
-                </pt>
-                <pt idx="1">
-                  <v>7810</v>
-                </pt>
-                <pt idx="2">
-                  <v>8225</v>
-                </pt>
-                <pt idx="3">
-                  <v>8425</v>
-                </pt>
-                <pt idx="4">
-                  <v>8434</v>
-                </pt>
-              </numCache>
-            </numRef>
-          </val>
-          <smooth val="0"/>
-        </ser>
-        <ser>
-          <idx val="6"/>
-          <order val="6"/>
-          <tx>
-            <v>Total</v>
-          </tx>
-          <spPr>
-            <a:ln>
-              <a:noFill/>
-              <a:prstDash val="solid"/>
-            </a:ln>
-          </spPr>
-          <marker>
-            <symbol val="none"/>
-            <spPr>
-              <a:ln>
-                <a:prstDash val="solid"/>
-              </a:ln>
-            </spPr>
-          </marker>
-          <dLbls>
-            <numFmt formatCode="#,##0"/>
-            <txPr>
-              <a:bodyPr/>
-              <a:p>
-                <a:pPr>
-                  <a:defRPr sz="1150" b="1" i="0">
-                    <a:solidFill>
-                      <a:srgbClr val="0B0B0B"/>
-                    </a:solidFill>
-                    <a:latin typeface="Aptos Narrow"/>
-                  </a:defRPr>
-                </a:pPr>
-                <a:r>
-                  <a:t/>
-                </a:r>
-                <a:endParaRPr sz="1150" b="1" i="0">
-                  <a:solidFill>
-                    <a:srgbClr val="0B0B0B"/>
-                  </a:solidFill>
-                  <a:latin typeface="Aptos Narrow"/>
-                </a:endParaRPr>
-              </a:p>
-            </txPr>
-            <dLblPos val="t"/>
+            <dLblPos val="ctr"/>
             <showLegendKey val="0"/>
             <showVal val="1"/>
             <showCatName val="0"/>
@@ -637,118 +462,48 @@
             <showPercent val="0"/>
             <showBubbleSize val="0"/>
           </dLbls>
+          <cat>
+            <strRef>
+              <f>'Chart Data'!$I$4:$L$4</f>
+              <strCache>
+                <ptCount val="4"/>
+                <pt idx="0">
+                  <v>Gross kill
+41,990</v>
+                </pt>
+                <pt idx="1">
+                  <v>After spec yield
+31,733  (-24%)</v>
+                </pt>
+                <pt idx="2">
+                  <v>After harvest yield
+21,891  (-31%)</v>
+                </pt>
+                <pt idx="3">
+                  <v>Peak demand Q4'27
+8,434</v>
+                </pt>
+              </strCache>
+            </strRef>
+          </cat>
           <val>
             <numRef>
-              <f>'Chart Data'!$B$9:$F$9</f>
+              <f>'Chart Data'!$I$9:$L$9</f>
               <numCache>
-                <formatCode>General</formatCode>
-                <ptCount val="5"/>
-                <pt idx="0">
-                  <v>31732.9759753593</v>
-                </pt>
-                <pt idx="1">
-                  <v>31732.9759753593</v>
-                </pt>
-                <pt idx="2">
-                  <v>31732.9759753593</v>
-                </pt>
+                <formatCode>#,##0</formatCode>
+                <ptCount val="4"/>
                 <pt idx="3">
-                  <v>31732.9759753593</v>
-                </pt>
-                <pt idx="4">
-                  <v>31732.9759753593</v>
+                  <v>8434</v>
                 </pt>
               </numCache>
             </numRef>
           </val>
-          <smooth val="0"/>
         </ser>
-        <axId val="10"/>
-        <axId val="200"/>
-      </lineChart>
-      <lineChart>
-        <grouping val="standard"/>
-        <ser>
-          <idx val="7"/>
-          <order val="7"/>
-          <tx>
-            <v>Total</v>
-          </tx>
-          <spPr>
-            <a:ln>
-              <a:noFill/>
-              <a:prstDash val="solid"/>
-            </a:ln>
-          </spPr>
-          <marker>
-            <symbol val="none"/>
-            <spPr>
-              <a:ln>
-                <a:prstDash val="solid"/>
-              </a:ln>
-            </spPr>
-          </marker>
-          <dLbls>
-            <numFmt formatCode="#,##0"/>
-            <txPr>
-              <a:bodyPr/>
-              <a:p>
-                <a:pPr>
-                  <a:defRPr sz="1150" b="1" i="0">
-                    <a:solidFill>
-                      <a:srgbClr val="0B0B0B"/>
-                    </a:solidFill>
-                    <a:latin typeface="Aptos Narrow"/>
-                  </a:defRPr>
-                </a:pPr>
-                <a:r>
-                  <a:t/>
-                </a:r>
-                <a:endParaRPr sz="1150" b="1" i="0">
-                  <a:solidFill>
-                    <a:srgbClr val="0B0B0B"/>
-                  </a:solidFill>
-                  <a:latin typeface="Aptos Narrow"/>
-                </a:endParaRPr>
-              </a:p>
-            </txPr>
-            <dLblPos val="t"/>
-            <showLegendKey val="0"/>
-            <showVal val="1"/>
-            <showCatName val="0"/>
-            <showSerName val="0"/>
-            <showPercent val="0"/>
-            <showBubbleSize val="0"/>
-          </dLbls>
-          <val>
-            <numRef>
-              <f>'Chart Data'!$B$15:$F$15</f>
-              <numCache>
-                <formatCode>General</formatCode>
-                <ptCount val="5"/>
-                <pt idx="0">
-                  <v>41990</v>
-                </pt>
-                <pt idx="1">
-                  <v>41990</v>
-                </pt>
-                <pt idx="2">
-                  <v>41990</v>
-                </pt>
-                <pt idx="3">
-                  <v>41990</v>
-                </pt>
-                <pt idx="4">
-                  <v>41990</v>
-                </pt>
-              </numCache>
-            </numRef>
-          </val>
-          <smooth val="0"/>
-        </ser>
+        <gapWidth val="120"/>
+        <overlap val="100"/>
         <axId val="10"/>
         <axId val="100"/>
-      </lineChart>
+      </barChart>
       <catAx>
         <axId val="10"/>
         <scaling>
@@ -812,7 +567,7 @@
             </a:ln>
           </spPr>
         </majorGridlines>
-        <numFmt formatCode="[=0]0;#,##0,&quot;K&quot;" sourceLinked="0"/>
+        <numFmt formatCode="#,##0" sourceLinked="0"/>
         <majorTickMark val="none"/>
         <minorTickMark val="none"/>
         <tickLblPos val="nextTo"/>
@@ -847,43 +602,9 @@
         <crossAx val="10"/>
         <majorUnit val="10000"/>
       </valAx>
-      <valAx>
-        <axId val="200"/>
-        <scaling>
-          <orientation val="minMax"/>
-          <max val="45000"/>
-          <min val="0"/>
-        </scaling>
-        <delete val="1"/>
-        <axPos val="l"/>
-        <numFmt formatCode="[=0]0;#,##0,&quot;K&quot;" sourceLinked="0"/>
-        <majorTickMark val="none"/>
-        <minorTickMark val="none"/>
-        <crossAx val="10"/>
-      </valAx>
     </plotArea>
     <legend>
       <legendPos val="b"/>
-      <legendEntry>
-        <idx val="6"/>
-        <delete val="1"/>
-      </legendEntry>
-      <legendEntry>
-        <idx val="7"/>
-        <delete val="1"/>
-      </legendEntry>
-      <layout>
-        <manualLayout>
-          <xMode val="edge"/>
-          <yMode val="edge"/>
-          <wMode val="factor"/>
-          <hMode val="factor"/>
-          <x val="0.1"/>
-          <y val="0.93"/>
-          <w val="0.8"/>
-          <h val="0.06"/>
-        </manualLayout>
-      </layout>
       <overlay val="0"/>
       <txPr>
         <a:bodyPr/>
@@ -985,22 +706,22 @@
             <numRef>
               <f>'Chart Data'!$B$9:$F$9</f>
               <numCache>
-                <formatCode>General</formatCode>
+                <formatCode>#,##0</formatCode>
                 <ptCount val="5"/>
                 <pt idx="0">
-                  <v>31732.9759753593</v>
+                  <v>31733</v>
                 </pt>
                 <pt idx="1">
-                  <v>31732.9759753593</v>
+                  <v>31733</v>
                 </pt>
                 <pt idx="2">
-                  <v>31732.9759753593</v>
+                  <v>31733</v>
                 </pt>
                 <pt idx="3">
-                  <v>31732.9759753593</v>
+                  <v>31733</v>
                 </pt>
                 <pt idx="4">
-                  <v>31732.9759753593</v>
+                  <v>31733</v>
                 </pt>
               </numCache>
             </numRef>
@@ -1048,22 +769,22 @@
             <numRef>
               <f>'Chart Data'!$B$16:$F$16</f>
               <numCache>
-                <formatCode>General</formatCode>
+                <formatCode>#,##0</formatCode>
                 <ptCount val="5"/>
                 <pt idx="0">
-                  <v>10257.0240246407</v>
+                  <v>10257</v>
                 </pt>
                 <pt idx="1">
-                  <v>10257.0240246407</v>
+                  <v>10257</v>
                 </pt>
                 <pt idx="2">
-                  <v>10257.0240246407</v>
+                  <v>10257</v>
                 </pt>
                 <pt idx="3">
-                  <v>10257.0240246407</v>
+                  <v>10257</v>
                 </pt>
                 <pt idx="4">
-                  <v>10257.0240246407</v>
+                  <v>10257</v>
                 </pt>
               </numCache>
             </numRef>
@@ -1105,7 +826,29 @@
           <dLbls>
             <dLbl>
               <idx val="0"/>
-              <numFmt formatCode="#,##0"/>
+              <numFmt formatCode="#,##0" sourceLinked="0"/>
+              <txPr>
+                <a:bodyPr/>
+                <a:p>
+                  <a:pPr>
+                    <a:defRPr sz="1150" b="1" i="0">
+                      <a:solidFill>
+                        <a:srgbClr val="FFFFFF"/>
+                      </a:solidFill>
+                      <a:latin typeface="Aptos Narrow"/>
+                    </a:defRPr>
+                  </a:pPr>
+                  <a:r>
+                    <a:t/>
+                  </a:r>
+                  <a:endParaRPr sz="1150" b="1" i="0">
+                    <a:solidFill>
+                      <a:srgbClr val="FFFFFF"/>
+                    </a:solidFill>
+                    <a:latin typeface="Aptos Narrow"/>
+                  </a:endParaRPr>
+                </a:p>
+              </txPr>
               <dLblPos val="ctr"/>
               <showLegendKey val="0"/>
               <showVal val="1"/>
@@ -1114,7 +857,7 @@
               <showPercent val="0"/>
               <showBubbleSize val="0"/>
             </dLbl>
-            <numFmt formatCode="#,##0"/>
+            <numFmt formatCode="#,##0" sourceLinked="0"/>
             <txPr>
               <a:bodyPr/>
               <a:p>
@@ -1148,22 +891,22 @@
             <numRef>
               <f>'Chart Data'!$B$10:$F$10</f>
               <numCache>
-                <formatCode>General</formatCode>
+                <formatCode>#,##0</formatCode>
                 <ptCount val="5"/>
                 <pt idx="0">
-                  <v>17220.7857529863</v>
+                  <v>17221</v>
                 </pt>
                 <pt idx="1">
-                  <v>17220.7857529863</v>
+                  <v>17221</v>
                 </pt>
                 <pt idx="2">
-                  <v>17220.7857529863</v>
+                  <v>17221</v>
                 </pt>
                 <pt idx="3">
-                  <v>17220.7857529863</v>
+                  <v>17221</v>
                 </pt>
                 <pt idx="4">
-                  <v>17220.7857529863</v>
+                  <v>17221</v>
                 </pt>
               </numCache>
             </numRef>
@@ -1198,22 +941,22 @@
             <numRef>
               <f>'Chart Data'!$B$11:$F$11</f>
               <numCache>
-                <formatCode>General</formatCode>
+                <formatCode>#,##0</formatCode>
                 <ptCount val="5"/>
                 <pt idx="0">
-                  <v>1239.89657421501</v>
+                  <v>1240</v>
                 </pt>
                 <pt idx="1">
-                  <v>1239.89657421501</v>
+                  <v>1240</v>
                 </pt>
                 <pt idx="2">
-                  <v>1239.89657421501</v>
+                  <v>1240</v>
                 </pt>
                 <pt idx="3">
-                  <v>1239.89657421501</v>
+                  <v>1240</v>
                 </pt>
                 <pt idx="4">
-                  <v>1239.89657421501</v>
+                  <v>1240</v>
                 </pt>
               </numCache>
             </numRef>
@@ -1248,22 +991,22 @@
             <numRef>
               <f>'Chart Data'!$B$12:$F$12</f>
               <numCache>
-                <formatCode>General</formatCode>
+                <formatCode>#,##0</formatCode>
                 <ptCount val="5"/>
                 <pt idx="0">
-                  <v>1033.24714517918</v>
+                  <v>1033</v>
                 </pt>
                 <pt idx="1">
-                  <v>1033.24714517918</v>
+                  <v>1033</v>
                 </pt>
                 <pt idx="2">
-                  <v>1033.24714517918</v>
+                  <v>1033</v>
                 </pt>
                 <pt idx="3">
-                  <v>1033.24714517918</v>
+                  <v>1033</v>
                 </pt>
                 <pt idx="4">
-                  <v>1033.24714517918</v>
+                  <v>1033</v>
                 </pt>
               </numCache>
             </numRef>
@@ -1298,22 +1041,22 @@
             <numRef>
               <f>'Chart Data'!$B$13:$F$13</f>
               <numCache>
-                <formatCode>General</formatCode>
+                <formatCode>#,##0</formatCode>
                 <ptCount val="5"/>
                 <pt idx="0">
-                  <v>2396.61114142236</v>
+                  <v>2397</v>
                 </pt>
                 <pt idx="1">
-                  <v>2396.61114142236</v>
+                  <v>2397</v>
                 </pt>
                 <pt idx="2">
-                  <v>2396.61114142236</v>
+                  <v>2397</v>
                 </pt>
                 <pt idx="3">
-                  <v>2396.61114142236</v>
+                  <v>2397</v>
                 </pt>
                 <pt idx="4">
-                  <v>2396.61114142236</v>
+                  <v>2397</v>
                 </pt>
               </numCache>
             </numRef>
@@ -1351,7 +1094,29 @@
           <dLbls>
             <dLbl>
               <idx val="4"/>
-              <numFmt formatCode="#,##0"/>
+              <numFmt formatCode="#,##0" sourceLinked="0"/>
+              <txPr>
+                <a:bodyPr/>
+                <a:p>
+                  <a:pPr>
+                    <a:defRPr sz="1150" b="1" i="0">
+                      <a:solidFill>
+                        <a:srgbClr val="FFFFFF"/>
+                      </a:solidFill>
+                      <a:latin typeface="Aptos Narrow"/>
+                    </a:defRPr>
+                  </a:pPr>
+                  <a:r>
+                    <a:t/>
+                  </a:r>
+                  <a:endParaRPr sz="1150" b="1" i="0">
+                    <a:solidFill>
+                      <a:srgbClr val="FFFFFF"/>
+                    </a:solidFill>
+                    <a:latin typeface="Aptos Narrow"/>
+                  </a:endParaRPr>
+                </a:p>
+              </txPr>
               <dLblPos val="t"/>
               <showLegendKey val="0"/>
               <showVal val="1"/>
@@ -1360,7 +1125,7 @@
               <showPercent val="0"/>
               <showBubbleSize val="0"/>
             </dLbl>
-            <numFmt formatCode="#,##0"/>
+            <numFmt formatCode="#,##0" sourceLinked="0"/>
             <txPr>
               <a:bodyPr/>
               <a:p>
@@ -1394,7 +1159,7 @@
             <numRef>
               <f>'Chart Data'!$B$21:$F$21</f>
               <numCache>
-                <formatCode>General</formatCode>
+                <formatCode>#,##0</formatCode>
                 <ptCount val="5"/>
                 <pt idx="0">
                   <v>7305</v>
@@ -1437,7 +1202,7 @@
             </spPr>
           </marker>
           <dLbls>
-            <numFmt formatCode="#,##0"/>
+            <numFmt formatCode="#,##0" sourceLinked="0"/>
             <txPr>
               <a:bodyPr/>
               <a:p>
@@ -1472,22 +1237,22 @@
             <numRef>
               <f>'Chart Data'!$B$14:$F$14</f>
               <numCache>
-                <formatCode>General</formatCode>
+                <formatCode>#,##0</formatCode>
                 <ptCount val="5"/>
                 <pt idx="0">
-                  <v>21890.5406138028</v>
+                  <v>21891</v>
                 </pt>
                 <pt idx="1">
-                  <v>21890.5406138028</v>
+                  <v>21891</v>
                 </pt>
                 <pt idx="2">
-                  <v>21890.5406138028</v>
+                  <v>21891</v>
                 </pt>
                 <pt idx="3">
-                  <v>21890.5406138028</v>
+                  <v>21891</v>
                 </pt>
                 <pt idx="4">
-                  <v>21890.5406138028</v>
+                  <v>21891</v>
                 </pt>
               </numCache>
             </numRef>
@@ -1520,7 +1285,7 @@
             </spPr>
           </marker>
           <dLbls>
-            <numFmt formatCode="#,##0"/>
+            <numFmt formatCode="#,##0" sourceLinked="0"/>
             <txPr>
               <a:bodyPr/>
               <a:p>
@@ -1555,7 +1320,7 @@
             <numRef>
               <f>'Chart Data'!$B$15:$F$15</f>
               <numCache>
-                <formatCode>General</formatCode>
+                <formatCode>#,##0</formatCode>
                 <ptCount val="5"/>
                 <pt idx="0">
                   <v>41990</v>
@@ -1643,7 +1408,7 @@
             </a:ln>
           </spPr>
         </majorGridlines>
-        <numFmt formatCode="[=0]0;#,##0,&quot;K&quot;" sourceLinked="0"/>
+        <numFmt formatCode="#,##0" sourceLinked="0"/>
         <majorTickMark val="none"/>
         <minorTickMark val="none"/>
         <tickLblPos val="nextTo"/>
@@ -1765,9 +1530,9 @@
           <yMode val="edge"/>
           <wMode val="factor"/>
           <hMode val="factor"/>
-          <x val="0.09"/>
+          <x val="0.055"/>
           <y val="0.05"/>
-          <w val="0.89"/>
+          <w val="0.93"/>
           <h val="0.78"/>
         </manualLayout>
       </layout>
@@ -1777,6 +1542,77 @@
         <ser>
           <idx val="0"/>
           <order val="0"/>
+          <tx>
+            <v>Gross kill</v>
+          </tx>
+          <spPr>
+            <a:solidFill>
+              <a:srgbClr val="D9D9D9"/>
+            </a:solidFill>
+            <a:ln>
+              <a:noFill/>
+              <a:prstDash val="solid"/>
+            </a:ln>
+          </spPr>
+          <cat>
+            <strRef>
+              <f>'Chart Data'!$B$4:$F$4</f>
+              <strCache>
+                <ptCount val="5"/>
+                <pt idx="0">
+                  <v>Q4'26</v>
+                </pt>
+                <pt idx="1">
+                  <v>Q1'27</v>
+                </pt>
+                <pt idx="2">
+                  <v>Q2'27</v>
+                </pt>
+                <pt idx="3">
+                  <v>Q3'27</v>
+                </pt>
+                <pt idx="4">
+                  <v>Q4'27</v>
+                </pt>
+              </strCache>
+            </strRef>
+          </cat>
+          <val>
+            <numRef>
+              <f>'Chart Data'!$B$15:$F$15</f>
+              <numCache>
+                <formatCode>#,##0</formatCode>
+                <ptCount val="5"/>
+                <pt idx="0">
+                  <v>41990</v>
+                </pt>
+                <pt idx="1">
+                  <v>41990</v>
+                </pt>
+                <pt idx="2">
+                  <v>41990</v>
+                </pt>
+                <pt idx="3">
+                  <v>41990</v>
+                </pt>
+                <pt idx="4">
+                  <v>41990</v>
+                </pt>
+              </numCache>
+            </numRef>
+          </val>
+        </ser>
+        <gapWidth val="50"/>
+        <overlap val="100"/>
+        <axId val="10"/>
+        <axId val="100"/>
+      </barChart>
+      <barChart>
+        <barDir val="col"/>
+        <grouping val="stacked"/>
+        <ser>
+          <idx val="1"/>
+          <order val="1"/>
           <tx>
             <strRef>
               <f>Sheet1!$D$16</f>
@@ -1802,7 +1638,29 @@
           <dLbls>
             <dLbl>
               <idx val="0"/>
-              <numFmt formatCode="#,##0"/>
+              <numFmt formatCode="#,##0" sourceLinked="0"/>
+              <txPr>
+                <a:bodyPr/>
+                <a:p>
+                  <a:pPr>
+                    <a:defRPr sz="1150" b="1" i="0">
+                      <a:solidFill>
+                        <a:srgbClr val="FFFFFF"/>
+                      </a:solidFill>
+                      <a:latin typeface="Aptos Narrow"/>
+                    </a:defRPr>
+                  </a:pPr>
+                  <a:r>
+                    <a:t/>
+                  </a:r>
+                  <a:endParaRPr sz="1150" b="1" i="0">
+                    <a:solidFill>
+                      <a:srgbClr val="FFFFFF"/>
+                    </a:solidFill>
+                    <a:latin typeface="Aptos Narrow"/>
+                  </a:endParaRPr>
+                </a:p>
+              </txPr>
               <dLblPos val="ctr"/>
               <showLegendKey val="0"/>
               <showVal val="1"/>
@@ -1811,12 +1669,12 @@
               <showPercent val="0"/>
               <showBubbleSize val="0"/>
             </dLbl>
-            <numFmt formatCode="#,##0"/>
+            <numFmt formatCode="#,##0" sourceLinked="0"/>
             <txPr>
               <a:bodyPr/>
               <a:p>
                 <a:pPr>
-                  <a:defRPr sz="1300" b="1" i="0">
+                  <a:defRPr sz="1150" b="1" i="0">
                     <a:solidFill>
                       <a:srgbClr val="FFFFFF"/>
                     </a:solidFill>
@@ -1826,7 +1684,7 @@
                 <a:r>
                   <a:t/>
                 </a:r>
-                <a:endParaRPr sz="1300" b="1" i="0">
+                <a:endParaRPr sz="1150" b="1" i="0">
                   <a:solidFill>
                     <a:srgbClr val="FFFFFF"/>
                   </a:solidFill>
@@ -1841,57 +1699,34 @@
             <showPercent val="0"/>
             <showBubbleSize val="0"/>
           </dLbls>
-          <cat>
-            <strRef>
-              <f>'Chart Data'!$B$4:$F$4</f>
-              <strCache>
+          <val>
+            <numRef>
+              <f>'Chart Data'!$B$5:$F$5</f>
+              <numCache>
+                <formatCode>#,##0</formatCode>
                 <ptCount val="5"/>
                 <pt idx="0">
-                  <v>Q4'26</v>
+                  <v>24964</v>
                 </pt>
                 <pt idx="1">
-                  <v>Q1'27</v>
+                  <v>24964</v>
                 </pt>
                 <pt idx="2">
-                  <v>Q2'27</v>
+                  <v>24964</v>
                 </pt>
                 <pt idx="3">
-                  <v>Q3'27</v>
+                  <v>24964</v>
                 </pt>
                 <pt idx="4">
-                  <v>Q4'27</v>
-                </pt>
-              </strCache>
-            </strRef>
-          </cat>
-          <val>
-            <numRef>
-              <f>'Chart Data'!$B$10:$F$10</f>
-              <numCache>
-                <formatCode>General</formatCode>
-                <ptCount val="5"/>
-                <pt idx="0">
-                  <v>17220.7857529863</v>
-                </pt>
-                <pt idx="1">
-                  <v>17220.7857529863</v>
-                </pt>
-                <pt idx="2">
-                  <v>17220.7857529863</v>
-                </pt>
-                <pt idx="3">
-                  <v>17220.7857529863</v>
-                </pt>
-                <pt idx="4">
-                  <v>17220.7857529863</v>
+                  <v>24964</v>
                 </pt>
               </numCache>
             </numRef>
           </val>
         </ser>
         <ser>
-          <idx val="1"/>
-          <order val="1"/>
+          <idx val="2"/>
+          <order val="2"/>
           <tx>
             <strRef>
               <f>Sheet1!$D$17</f>
@@ -1914,57 +1749,34 @@
               <a:prstDash val="solid"/>
             </a:ln>
           </spPr>
-          <cat>
-            <strRef>
-              <f>'Chart Data'!$B$4:$F$4</f>
-              <strCache>
+          <val>
+            <numRef>
+              <f>'Chart Data'!$B$6:$F$6</f>
+              <numCache>
+                <formatCode>#,##0</formatCode>
                 <ptCount val="5"/>
                 <pt idx="0">
-                  <v>Q4'26</v>
+                  <v>1797</v>
                 </pt>
                 <pt idx="1">
-                  <v>Q1'27</v>
+                  <v>1797</v>
                 </pt>
                 <pt idx="2">
-                  <v>Q2'27</v>
+                  <v>1797</v>
                 </pt>
                 <pt idx="3">
-                  <v>Q3'27</v>
+                  <v>1797</v>
                 </pt>
                 <pt idx="4">
-                  <v>Q4'27</v>
-                </pt>
-              </strCache>
-            </strRef>
-          </cat>
-          <val>
-            <numRef>
-              <f>'Chart Data'!$B$11:$F$11</f>
-              <numCache>
-                <formatCode>General</formatCode>
-                <ptCount val="5"/>
-                <pt idx="0">
-                  <v>1239.89657421501</v>
-                </pt>
-                <pt idx="1">
-                  <v>1239.89657421501</v>
-                </pt>
-                <pt idx="2">
-                  <v>1239.89657421501</v>
-                </pt>
-                <pt idx="3">
-                  <v>1239.89657421501</v>
-                </pt>
-                <pt idx="4">
-                  <v>1239.89657421501</v>
+                  <v>1797</v>
                 </pt>
               </numCache>
             </numRef>
           </val>
         </ser>
         <ser>
-          <idx val="2"/>
-          <order val="2"/>
+          <idx val="3"/>
+          <order val="3"/>
           <tx>
             <strRef>
               <f>Sheet1!$D$18</f>
@@ -1987,57 +1799,34 @@
               <a:prstDash val="solid"/>
             </a:ln>
           </spPr>
-          <cat>
-            <strRef>
-              <f>'Chart Data'!$B$4:$F$4</f>
-              <strCache>
+          <val>
+            <numRef>
+              <f>'Chart Data'!$B$7:$F$7</f>
+              <numCache>
+                <formatCode>#,##0</formatCode>
                 <ptCount val="5"/>
                 <pt idx="0">
-                  <v>Q4'26</v>
+                  <v>1498</v>
                 </pt>
                 <pt idx="1">
-                  <v>Q1'27</v>
+                  <v>1498</v>
                 </pt>
                 <pt idx="2">
-                  <v>Q2'27</v>
+                  <v>1498</v>
                 </pt>
                 <pt idx="3">
-                  <v>Q3'27</v>
+                  <v>1498</v>
                 </pt>
                 <pt idx="4">
-                  <v>Q4'27</v>
-                </pt>
-              </strCache>
-            </strRef>
-          </cat>
-          <val>
-            <numRef>
-              <f>'Chart Data'!$B$12:$F$12</f>
-              <numCache>
-                <formatCode>General</formatCode>
-                <ptCount val="5"/>
-                <pt idx="0">
-                  <v>1033.24714517918</v>
-                </pt>
-                <pt idx="1">
-                  <v>1033.24714517918</v>
-                </pt>
-                <pt idx="2">
-                  <v>1033.24714517918</v>
-                </pt>
-                <pt idx="3">
-                  <v>1033.24714517918</v>
-                </pt>
-                <pt idx="4">
-                  <v>1033.24714517918</v>
+                  <v>1498</v>
                 </pt>
               </numCache>
             </numRef>
           </val>
         </ser>
         <ser>
-          <idx val="3"/>
-          <order val="3"/>
+          <idx val="4"/>
+          <order val="4"/>
           <tx>
             <strRef>
               <f>Sheet1!$D$19</f>
@@ -2060,64 +1849,105 @@
               <a:prstDash val="solid"/>
             </a:ln>
           </spPr>
-          <cat>
-            <strRef>
-              <f>'Chart Data'!$B$4:$F$4</f>
-              <strCache>
+          <dLbls>
+            <dLbl>
+              <idx val="0"/>
+              <numFmt formatCode="#,##0" sourceLinked="0"/>
+              <txPr>
+                <a:bodyPr/>
+                <a:p>
+                  <a:pPr>
+                    <a:defRPr sz="1150" b="1" i="0">
+                      <a:solidFill>
+                        <a:srgbClr val="0B0B0B"/>
+                      </a:solidFill>
+                      <a:latin typeface="Aptos Narrow"/>
+                    </a:defRPr>
+                  </a:pPr>
+                  <a:r>
+                    <a:t/>
+                  </a:r>
+                  <a:endParaRPr sz="1150" b="1" i="0">
+                    <a:solidFill>
+                      <a:srgbClr val="0B0B0B"/>
+                    </a:solidFill>
+                    <a:latin typeface="Aptos Narrow"/>
+                  </a:endParaRPr>
+                </a:p>
+              </txPr>
+              <dLblPos val="ctr"/>
+              <showLegendKey val="0"/>
+              <showVal val="1"/>
+              <showCatName val="0"/>
+              <showSerName val="0"/>
+              <showPercent val="0"/>
+              <showBubbleSize val="0"/>
+            </dLbl>
+            <numFmt formatCode="#,##0" sourceLinked="0"/>
+            <txPr>
+              <a:bodyPr/>
+              <a:p>
+                <a:pPr>
+                  <a:defRPr sz="1150" b="1" i="0">
+                    <a:solidFill>
+                      <a:srgbClr val="0B0B0B"/>
+                    </a:solidFill>
+                    <a:latin typeface="Aptos Narrow"/>
+                  </a:defRPr>
+                </a:pPr>
+                <a:r>
+                  <a:t/>
+                </a:r>
+                <a:endParaRPr sz="1150" b="1" i="0">
+                  <a:solidFill>
+                    <a:srgbClr val="0B0B0B"/>
+                  </a:solidFill>
+                  <a:latin typeface="Aptos Narrow"/>
+                </a:endParaRPr>
+              </a:p>
+            </txPr>
+            <showLegendKey val="0"/>
+            <showVal val="0"/>
+            <showCatName val="0"/>
+            <showSerName val="0"/>
+            <showPercent val="0"/>
+            <showBubbleSize val="0"/>
+          </dLbls>
+          <val>
+            <numRef>
+              <f>'Chart Data'!$B$8:$F$8</f>
+              <numCache>
+                <formatCode>#,##0</formatCode>
                 <ptCount val="5"/>
                 <pt idx="0">
-                  <v>Q4'26</v>
+                  <v>3474</v>
                 </pt>
                 <pt idx="1">
-                  <v>Q1'27</v>
+                  <v>3474</v>
                 </pt>
                 <pt idx="2">
-                  <v>Q2'27</v>
+                  <v>3474</v>
                 </pt>
                 <pt idx="3">
-                  <v>Q3'27</v>
+                  <v>3474</v>
                 </pt>
                 <pt idx="4">
-                  <v>Q4'27</v>
-                </pt>
-              </strCache>
-            </strRef>
-          </cat>
-          <val>
-            <numRef>
-              <f>'Chart Data'!$B$13:$F$13</f>
-              <numCache>
-                <formatCode>General</formatCode>
-                <ptCount val="5"/>
-                <pt idx="0">
-                  <v>2396.61114142236</v>
-                </pt>
-                <pt idx="1">
-                  <v>2396.61114142236</v>
-                </pt>
-                <pt idx="2">
-                  <v>2396.61114142236</v>
-                </pt>
-                <pt idx="3">
-                  <v>2396.61114142236</v>
-                </pt>
-                <pt idx="4">
-                  <v>2396.61114142236</v>
+                  <v>3474</v>
                 </pt>
               </numCache>
             </numRef>
           </val>
         </ser>
-        <gapWidth val="120"/>
+        <gapWidth val="200"/>
         <overlap val="100"/>
         <axId val="10"/>
-        <axId val="100"/>
+        <axId val="200"/>
       </barChart>
       <lineChart>
         <grouping val="standard"/>
         <ser>
-          <idx val="4"/>
-          <order val="4"/>
+          <idx val="5"/>
+          <order val="5"/>
           <tx>
             <v>Demand</v>
           </tx>
@@ -2140,7 +1970,29 @@
           <dLbls>
             <dLbl>
               <idx val="4"/>
-              <numFmt formatCode="#,##0"/>
+              <numFmt formatCode="#,##0" sourceLinked="0"/>
+              <txPr>
+                <a:bodyPr/>
+                <a:p>
+                  <a:pPr>
+                    <a:defRPr sz="1150" b="1" i="0">
+                      <a:solidFill>
+                        <a:srgbClr val="FFFFFF"/>
+                      </a:solidFill>
+                      <a:latin typeface="Aptos Narrow"/>
+                    </a:defRPr>
+                  </a:pPr>
+                  <a:r>
+                    <a:t/>
+                  </a:r>
+                  <a:endParaRPr sz="1150" b="1" i="0">
+                    <a:solidFill>
+                      <a:srgbClr val="FFFFFF"/>
+                    </a:solidFill>
+                    <a:latin typeface="Aptos Narrow"/>
+                  </a:endParaRPr>
+                </a:p>
+              </txPr>
               <dLblPos val="t"/>
               <showLegendKey val="0"/>
               <showVal val="1"/>
@@ -2149,12 +2001,12 @@
               <showPercent val="0"/>
               <showBubbleSize val="0"/>
             </dLbl>
-            <numFmt formatCode="#,##0"/>
+            <numFmt formatCode="#,##0" sourceLinked="0"/>
             <txPr>
               <a:bodyPr/>
               <a:p>
                 <a:pPr>
-                  <a:defRPr sz="1250" b="1" i="0">
+                  <a:defRPr sz="1150" b="1" i="0">
                     <a:solidFill>
                       <a:srgbClr val="FFFFFF"/>
                     </a:solidFill>
@@ -2164,7 +2016,7 @@
                 <a:r>
                   <a:t/>
                 </a:r>
-                <a:endParaRPr sz="1250" b="1" i="0">
+                <a:endParaRPr sz="1150" b="1" i="0">
                   <a:solidFill>
                     <a:srgbClr val="FFFFFF"/>
                   </a:solidFill>
@@ -2183,7 +2035,7 @@
             <numRef>
               <f>'Chart Data'!$B$21:$F$21</f>
               <numCache>
-                <formatCode>General</formatCode>
+                <formatCode>#,##0</formatCode>
                 <ptCount val="5"/>
                 <pt idx="0">
                   <v>7305</v>
@@ -2206,8 +2058,8 @@
           <smooth val="0"/>
         </ser>
         <ser>
-          <idx val="5"/>
-          <order val="5"/>
+          <idx val="6"/>
+          <order val="6"/>
           <tx>
             <v>Total</v>
           </tx>
@@ -2226,7 +2078,7 @@
             </spPr>
           </marker>
           <dLbls>
-            <numFmt formatCode="#,##0"/>
+            <numFmt formatCode="#,##0" sourceLinked="0"/>
             <txPr>
               <a:bodyPr/>
               <a:p>
@@ -2259,24 +2111,107 @@
           </dLbls>
           <val>
             <numRef>
-              <f>'Chart Data'!$B$14:$F$14</f>
+              <f>'Chart Data'!$B$9:$F$9</f>
               <numCache>
-                <formatCode>General</formatCode>
+                <formatCode>#,##0</formatCode>
                 <ptCount val="5"/>
                 <pt idx="0">
-                  <v>21890.5406138028</v>
+                  <v>31733</v>
                 </pt>
                 <pt idx="1">
-                  <v>21890.5406138028</v>
+                  <v>31733</v>
                 </pt>
                 <pt idx="2">
-                  <v>21890.5406138028</v>
+                  <v>31733</v>
                 </pt>
                 <pt idx="3">
-                  <v>21890.5406138028</v>
+                  <v>31733</v>
                 </pt>
                 <pt idx="4">
-                  <v>21890.5406138028</v>
+                  <v>31733</v>
+                </pt>
+              </numCache>
+            </numRef>
+          </val>
+          <smooth val="0"/>
+        </ser>
+        <axId val="10"/>
+        <axId val="200"/>
+      </lineChart>
+      <lineChart>
+        <grouping val="standard"/>
+        <ser>
+          <idx val="7"/>
+          <order val="7"/>
+          <tx>
+            <v>Total</v>
+          </tx>
+          <spPr>
+            <a:ln>
+              <a:noFill/>
+              <a:prstDash val="solid"/>
+            </a:ln>
+          </spPr>
+          <marker>
+            <symbol val="none"/>
+            <spPr>
+              <a:ln>
+                <a:prstDash val="solid"/>
+              </a:ln>
+            </spPr>
+          </marker>
+          <dLbls>
+            <numFmt formatCode="#,##0" sourceLinked="0"/>
+            <txPr>
+              <a:bodyPr/>
+              <a:p>
+                <a:pPr>
+                  <a:defRPr sz="1150" b="1" i="0">
+                    <a:solidFill>
+                      <a:srgbClr val="0B0B0B"/>
+                    </a:solidFill>
+                    <a:latin typeface="Aptos Narrow"/>
+                  </a:defRPr>
+                </a:pPr>
+                <a:r>
+                  <a:t/>
+                </a:r>
+                <a:endParaRPr sz="1150" b="1" i="0">
+                  <a:solidFill>
+                    <a:srgbClr val="0B0B0B"/>
+                  </a:solidFill>
+                  <a:latin typeface="Aptos Narrow"/>
+                </a:endParaRPr>
+              </a:p>
+            </txPr>
+            <dLblPos val="t"/>
+            <showLegendKey val="0"/>
+            <showVal val="1"/>
+            <showCatName val="0"/>
+            <showSerName val="0"/>
+            <showPercent val="0"/>
+            <showBubbleSize val="0"/>
+          </dLbls>
+          <val>
+            <numRef>
+              <f>'Chart Data'!$B$15:$F$15</f>
+              <numCache>
+                <formatCode>#,##0</formatCode>
+                <ptCount val="5"/>
+                <pt idx="0">
+                  <v>41990</v>
+                </pt>
+                <pt idx="1">
+                  <v>41990</v>
+                </pt>
+                <pt idx="2">
+                  <v>41990</v>
+                </pt>
+                <pt idx="3">
+                  <v>41990</v>
+                </pt>
+                <pt idx="4">
+                  <v>41990</v>
                 </pt>
               </numCache>
             </numRef>
@@ -2334,7 +2269,7 @@
         <axId val="100"/>
         <scaling>
           <orientation val="minMax"/>
-          <max val="25000"/>
+          <max val="45000"/>
           <min val="0"/>
         </scaling>
         <delete val="0"/>
@@ -2349,7 +2284,7 @@
             </a:ln>
           </spPr>
         </majorGridlines>
-        <numFmt formatCode="[=0]0;#,##0,&quot;K&quot;" sourceLinked="0"/>
+        <numFmt formatCode="#,##0" sourceLinked="0"/>
         <majorTickMark val="none"/>
         <minorTickMark val="none"/>
         <tickLblPos val="nextTo"/>
@@ -2382,15 +2317,45 @@
           </a:p>
         </txPr>
         <crossAx val="10"/>
-        <majorUnit val="5000"/>
+        <majorUnit val="10000"/>
+      </valAx>
+      <valAx>
+        <axId val="200"/>
+        <scaling>
+          <orientation val="minMax"/>
+          <max val="45000"/>
+          <min val="0"/>
+        </scaling>
+        <delete val="1"/>
+        <axPos val="l"/>
+        <numFmt formatCode="[=0]0;#,##0,&quot;K&quot;" sourceLinked="0"/>
+        <majorTickMark val="none"/>
+        <minorTickMark val="none"/>
+        <crossAx val="10"/>
       </valAx>
     </plotArea>
     <legend>
       <legendPos val="b"/>
       <legendEntry>
-        <idx val="5"/>
+        <idx val="6"/>
         <delete val="1"/>
       </legendEntry>
+      <legendEntry>
+        <idx val="7"/>
+        <delete val="1"/>
+      </legendEntry>
+      <layout>
+        <manualLayout>
+          <xMode val="edge"/>
+          <yMode val="edge"/>
+          <wMode val="factor"/>
+          <hMode val="factor"/>
+          <x val="0.1"/>
+          <y val="0.93"/>
+          <w val="0.8"/>
+          <h val="0.06"/>
+        </manualLayout>
+      </layout>
       <overlay val="0"/>
       <txPr>
         <a:bodyPr/>
@@ -2441,9 +2406,9 @@
           <yMode val="edge"/>
           <wMode val="factor"/>
           <hMode val="factor"/>
-          <x val="0.055"/>
+          <x val="0.09"/>
           <y val="0.05"/>
-          <w val="0.93"/>
+          <w val="0.89"/>
           <h val="0.78"/>
         </manualLayout>
       </layout>
@@ -2475,44 +2440,113 @@
               <a:prstDash val="solid"/>
             </a:ln>
           </spPr>
+          <dLbls>
+            <dLbl>
+              <idx val="0"/>
+              <numFmt formatCode="#,##0" sourceLinked="0"/>
+              <txPr>
+                <a:bodyPr/>
+                <a:p>
+                  <a:pPr>
+                    <a:defRPr sz="1300" b="1" i="0">
+                      <a:solidFill>
+                        <a:srgbClr val="FFFFFF"/>
+                      </a:solidFill>
+                      <a:latin typeface="Aptos Narrow"/>
+                    </a:defRPr>
+                  </a:pPr>
+                  <a:r>
+                    <a:t/>
+                  </a:r>
+                  <a:endParaRPr sz="1300" b="1" i="0">
+                    <a:solidFill>
+                      <a:srgbClr val="FFFFFF"/>
+                    </a:solidFill>
+                    <a:latin typeface="Aptos Narrow"/>
+                  </a:endParaRPr>
+                </a:p>
+              </txPr>
+              <dLblPos val="ctr"/>
+              <showLegendKey val="0"/>
+              <showVal val="1"/>
+              <showCatName val="0"/>
+              <showSerName val="0"/>
+              <showPercent val="0"/>
+              <showBubbleSize val="0"/>
+            </dLbl>
+            <numFmt formatCode="#,##0" sourceLinked="0"/>
+            <txPr>
+              <a:bodyPr/>
+              <a:p>
+                <a:pPr>
+                  <a:defRPr sz="1300" b="1" i="0">
+                    <a:solidFill>
+                      <a:srgbClr val="FFFFFF"/>
+                    </a:solidFill>
+                    <a:latin typeface="Aptos Narrow"/>
+                  </a:defRPr>
+                </a:pPr>
+                <a:r>
+                  <a:t/>
+                </a:r>
+                <a:endParaRPr sz="1300" b="1" i="0">
+                  <a:solidFill>
+                    <a:srgbClr val="FFFFFF"/>
+                  </a:solidFill>
+                  <a:latin typeface="Aptos Narrow"/>
+                </a:endParaRPr>
+              </a:p>
+            </txPr>
+            <showLegendKey val="0"/>
+            <showVal val="0"/>
+            <showCatName val="0"/>
+            <showSerName val="0"/>
+            <showPercent val="0"/>
+            <showBubbleSize val="0"/>
+          </dLbls>
           <cat>
             <strRef>
-              <f>'Chart Data'!$I$4:$L$4</f>
+              <f>'Chart Data'!$B$4:$F$4</f>
               <strCache>
-                <ptCount val="4"/>
+                <ptCount val="5"/>
                 <pt idx="0">
-                  <v>Gross kill
-41,990</v>
+                  <v>Q4'26</v>
                 </pt>
                 <pt idx="1">
-                  <v>After spec yield
-31,733  (-24%)</v>
+                  <v>Q1'27</v>
                 </pt>
                 <pt idx="2">
-                  <v>After harvest yield
-21,891  (-31%)</v>
+                  <v>Q2'27</v>
                 </pt>
                 <pt idx="3">
-                  <v>Peak demand Q4'27
-8,434</v>
+                  <v>Q3'27</v>
+                </pt>
+                <pt idx="4">
+                  <v>Q4'27</v>
                 </pt>
               </strCache>
             </strRef>
           </cat>
           <val>
             <numRef>
-              <f>'Chart Data'!$I$5:$L$5</f>
+              <f>'Chart Data'!$B$10:$F$10</f>
               <numCache>
-                <formatCode>General</formatCode>
-                <ptCount val="4"/>
+                <formatCode>#,##0</formatCode>
+                <ptCount val="5"/>
                 <pt idx="0">
-                  <v>32500</v>
+                  <v>17221</v>
                 </pt>
                 <pt idx="1">
-                  <v>24963.6036960986</v>
+                  <v>17221</v>
                 </pt>
                 <pt idx="2">
-                  <v>17220.7857529863</v>
+                  <v>17221</v>
+                </pt>
+                <pt idx="3">
+                  <v>17221</v>
+                </pt>
+                <pt idx="4">
+                  <v>17221</v>
                 </pt>
               </numCache>
             </numRef>
@@ -2545,42 +2579,47 @@
           </spPr>
           <cat>
             <strRef>
-              <f>'Chart Data'!$I$4:$L$4</f>
+              <f>'Chart Data'!$B$4:$F$4</f>
               <strCache>
-                <ptCount val="4"/>
+                <ptCount val="5"/>
                 <pt idx="0">
-                  <v>Gross kill
-41,990</v>
+                  <v>Q4'26</v>
                 </pt>
                 <pt idx="1">
-                  <v>After spec yield
-31,733  (-24%)</v>
+                  <v>Q1'27</v>
                 </pt>
                 <pt idx="2">
-                  <v>After harvest yield
-21,891  (-31%)</v>
+                  <v>Q2'27</v>
                 </pt>
                 <pt idx="3">
-                  <v>Peak demand Q4'27
-8,434</v>
+                  <v>Q3'27</v>
+                </pt>
+                <pt idx="4">
+                  <v>Q4'27</v>
                 </pt>
               </strCache>
             </strRef>
           </cat>
           <val>
             <numRef>
-              <f>'Chart Data'!$I$6:$L$6</f>
+              <f>'Chart Data'!$B$11:$F$11</f>
               <numCache>
-                <formatCode>General</formatCode>
-                <ptCount val="4"/>
+                <formatCode>#,##0</formatCode>
+                <ptCount val="5"/>
                 <pt idx="0">
-                  <v>2340</v>
+                  <v>1240</v>
                 </pt>
                 <pt idx="1">
-                  <v>1797.3794661191</v>
+                  <v>1240</v>
                 </pt>
                 <pt idx="2">
-                  <v>1239.89657421501</v>
+                  <v>1240</v>
+                </pt>
+                <pt idx="3">
+                  <v>1240</v>
+                </pt>
+                <pt idx="4">
+                  <v>1240</v>
                 </pt>
               </numCache>
             </numRef>
@@ -2613,42 +2652,47 @@
           </spPr>
           <cat>
             <strRef>
-              <f>'Chart Data'!$I$4:$L$4</f>
+              <f>'Chart Data'!$B$4:$F$4</f>
               <strCache>
-                <ptCount val="4"/>
+                <ptCount val="5"/>
                 <pt idx="0">
-                  <v>Gross kill
-41,990</v>
+                  <v>Q4'26</v>
                 </pt>
                 <pt idx="1">
-                  <v>After spec yield
-31,733  (-24%)</v>
+                  <v>Q1'27</v>
                 </pt>
                 <pt idx="2">
-                  <v>After harvest yield
-21,891  (-31%)</v>
+                  <v>Q2'27</v>
                 </pt>
                 <pt idx="3">
-                  <v>Peak demand Q4'27
-8,434</v>
+                  <v>Q3'27</v>
+                </pt>
+                <pt idx="4">
+                  <v>Q4'27</v>
                 </pt>
               </strCache>
             </strRef>
           </cat>
           <val>
             <numRef>
-              <f>'Chart Data'!$I$7:$L$7</f>
+              <f>'Chart Data'!$B$12:$F$12</f>
               <numCache>
-                <formatCode>General</formatCode>
-                <ptCount val="4"/>
+                <formatCode>#,##0</formatCode>
+                <ptCount val="5"/>
                 <pt idx="0">
-                  <v>1950</v>
+                  <v>1033</v>
                 </pt>
                 <pt idx="1">
-                  <v>1497.81622176591</v>
+                  <v>1033</v>
                 </pt>
                 <pt idx="2">
-                  <v>1033.24714517918</v>
+                  <v>1033</v>
+                </pt>
+                <pt idx="3">
+                  <v>1033</v>
+                </pt>
+                <pt idx="4">
+                  <v>1033</v>
                 </pt>
               </numCache>
             </numRef>
@@ -2681,79 +2725,121 @@
           </spPr>
           <cat>
             <strRef>
-              <f>'Chart Data'!$I$4:$L$4</f>
+              <f>'Chart Data'!$B$4:$F$4</f>
               <strCache>
-                <ptCount val="4"/>
+                <ptCount val="5"/>
                 <pt idx="0">
-                  <v>Gross kill
-41,990</v>
+                  <v>Q4'26</v>
                 </pt>
                 <pt idx="1">
-                  <v>After spec yield
-31,733  (-24%)</v>
+                  <v>Q1'27</v>
                 </pt>
                 <pt idx="2">
-                  <v>After harvest yield
-21,891  (-31%)</v>
+                  <v>Q2'27</v>
                 </pt>
                 <pt idx="3">
-                  <v>Peak demand Q4'27
-8,434</v>
+                  <v>Q3'27</v>
+                </pt>
+                <pt idx="4">
+                  <v>Q4'27</v>
                 </pt>
               </strCache>
             </strRef>
           </cat>
           <val>
             <numRef>
-              <f>'Chart Data'!$I$8:$L$8</f>
+              <f>'Chart Data'!$B$13:$F$13</f>
               <numCache>
-                <formatCode>General</formatCode>
-                <ptCount val="4"/>
+                <formatCode>#,##0</formatCode>
+                <ptCount val="5"/>
                 <pt idx="0">
-                  <v>5200</v>
+                  <v>2397</v>
                 </pt>
                 <pt idx="1">
-                  <v>3474.17659137577</v>
+                  <v>2397</v>
                 </pt>
                 <pt idx="2">
-                  <v>2396.61114142236</v>
+                  <v>2397</v>
+                </pt>
+                <pt idx="3">
+                  <v>2397</v>
+                </pt>
+                <pt idx="4">
+                  <v>2397</v>
                 </pt>
               </numCache>
             </numRef>
           </val>
         </ser>
+        <gapWidth val="120"/>
+        <overlap val="100"/>
+        <axId val="10"/>
+        <axId val="100"/>
+      </barChart>
+      <lineChart>
+        <grouping val="standard"/>
         <ser>
           <idx val="4"/>
           <order val="4"/>
           <tx>
-            <strRef>
-              <f>'Chart Data'!$H$9</f>
-              <strCache>
-                <ptCount val="1"/>
-                <pt idx="0">
-                  <v>Tissue demand</v>
-                </pt>
-              </strCache>
-            </strRef>
+            <v>Demand</v>
           </tx>
           <spPr>
-            <a:solidFill>
-              <a:srgbClr val="0B0B0B"/>
-            </a:solidFill>
-            <a:ln w="15875">
+            <a:ln w="19050" cap="rnd">
               <a:solidFill>
-                <a:srgbClr val="FFFFFF"/>
+                <a:srgbClr val="0B0B0B"/>
               </a:solidFill>
               <a:prstDash val="solid"/>
             </a:ln>
           </spPr>
+          <marker>
+            <symbol val="none"/>
+            <spPr>
+              <a:ln>
+                <a:prstDash val="solid"/>
+              </a:ln>
+            </spPr>
+          </marker>
           <dLbls>
-            <numFmt formatCode="#,##0"/>
+            <dLbl>
+              <idx val="4"/>
+              <numFmt formatCode="#,##0" sourceLinked="0"/>
+              <txPr>
+                <a:bodyPr/>
+                <a:p>
+                  <a:pPr>
+                    <a:defRPr sz="1250" b="1" i="0">
+                      <a:solidFill>
+                        <a:srgbClr val="FFFFFF"/>
+                      </a:solidFill>
+                      <a:latin typeface="Aptos Narrow"/>
+                    </a:defRPr>
+                  </a:pPr>
+                  <a:r>
+                    <a:t/>
+                  </a:r>
+                  <a:endParaRPr sz="1250" b="1" i="0">
+                    <a:solidFill>
+                      <a:srgbClr val="FFFFFF"/>
+                    </a:solidFill>
+                    <a:latin typeface="Aptos Narrow"/>
+                  </a:endParaRPr>
+                </a:p>
+              </txPr>
+              <dLblPos val="t"/>
+              <showLegendKey val="0"/>
+              <showVal val="1"/>
+              <showCatName val="0"/>
+              <showSerName val="0"/>
+              <showPercent val="0"/>
+              <showBubbleSize val="0"/>
+            </dLbl>
+            <numFmt formatCode="#,##0" sourceLinked="0"/>
             <txPr>
               <a:bodyPr/>
               <a:p>
                 <a:pPr>
-                  <a:defRPr sz="1150" b="1" i="0">
+                  <a:defRPr sz="1250" b="1" i="0">
                     <a:solidFill>
                       <a:srgbClr val="FFFFFF"/>
                     </a:solidFill>
@@ -2763,7 +2849,7 @@
                 <a:r>
                   <a:t/>
                 </a:r>
-                <a:endParaRPr sz="1150" b="1" i="0">
+                <a:endParaRPr sz="1250" b="1" i="0">
                   <a:solidFill>
                     <a:srgbClr val="FFFFFF"/>
                   </a:solidFill>
@@ -2771,7 +2857,84 @@
                 </a:endParaRPr>
               </a:p>
             </txPr>
-            <dLblPos val="ctr"/>
+            <showLegendKey val="0"/>
+            <showVal val="0"/>
+            <showCatName val="0"/>
+            <showSerName val="0"/>
+            <showPercent val="0"/>
+            <showBubbleSize val="0"/>
+          </dLbls>
+          <val>
+            <numRef>
+              <f>'Chart Data'!$B$21:$F$21</f>
+              <numCache>
+                <formatCode>#,##0</formatCode>
+                <ptCount val="5"/>
+                <pt idx="0">
+                  <v>7305</v>
+                </pt>
+                <pt idx="1">
+                  <v>7810</v>
+                </pt>
+                <pt idx="2">
+                  <v>8225</v>
+                </pt>
+                <pt idx="3">
+                  <v>8425</v>
+                </pt>
+                <pt idx="4">
+                  <v>8434</v>
+                </pt>
+              </numCache>
+            </numRef>
+          </val>
+          <smooth val="0"/>
+        </ser>
+        <ser>
+          <idx val="5"/>
+          <order val="5"/>
+          <tx>
+            <v>Total</v>
+          </tx>
+          <spPr>
+            <a:ln>
+              <a:noFill/>
+              <a:prstDash val="solid"/>
+            </a:ln>
+          </spPr>
+          <marker>
+            <symbol val="none"/>
+            <spPr>
+              <a:ln>
+                <a:prstDash val="solid"/>
+              </a:ln>
+            </spPr>
+          </marker>
+          <dLbls>
+            <numFmt formatCode="#,##0" sourceLinked="0"/>
+            <txPr>
+              <a:bodyPr/>
+              <a:p>
+                <a:pPr>
+                  <a:defRPr sz="1150" b="1" i="0">
+                    <a:solidFill>
+                      <a:srgbClr val="0B0B0B"/>
+                    </a:solidFill>
+                    <a:latin typeface="Aptos Narrow"/>
+                  </a:defRPr>
+                </a:pPr>
+                <a:r>
+                  <a:t/>
+                </a:r>
+                <a:endParaRPr sz="1150" b="1" i="0">
+                  <a:solidFill>
+                    <a:srgbClr val="0B0B0B"/>
+                  </a:solidFill>
+                  <a:latin typeface="Aptos Narrow"/>
+                </a:endParaRPr>
+              </a:p>
+            </txPr>
+            <dLblPos val="t"/>
             <showLegendKey val="0"/>
             <showVal val="1"/>
             <showCatName val="0"/>
@@ -2779,48 +2942,35 @@
             <showPercent val="0"/>
             <showBubbleSize val="0"/>
           </dLbls>
-          <cat>
-            <strRef>
-              <f>'Chart Data'!$I$4:$L$4</f>
-              <strCache>
-                <ptCount val="4"/>
-                <pt idx="0">
-                  <v>Gross kill
-41,990</v>
-                </pt>
-                <pt idx="1">
-                  <v>After spec yield
-31,733  (-24%)</v>
-                </pt>
-                <pt idx="2">
-                  <v>After harvest yield
-21,891  (-31%)</v>
-                </pt>
-                <pt idx="3">
-                  <v>Peak demand Q4'27
-8,434</v>
-                </pt>
-              </strCache>
-            </strRef>
-          </cat>
           <val>
             <numRef>
-              <f>'Chart Data'!$I$9:$L$9</f>
+              <f>'Chart Data'!$B$14:$F$14</f>
               <numCache>
-                <formatCode>General</formatCode>
-                <ptCount val="4"/>
+                <formatCode>#,##0</formatCode>
+                <ptCount val="5"/>
+                <pt idx="0">
+                  <v>21891</v>
+                </pt>
+                <pt idx="1">
+                  <v>21891</v>
+                </pt>
+                <pt idx="2">
+                  <v>21891</v>
+                </pt>
                 <pt idx="3">
-                  <v>8434</v>
+                  <v>21891</v>
+                </pt>
+                <pt idx="4">
+                  <v>21891</v>
                 </pt>
               </numCache>
             </numRef>
           </val>
+          <smooth val="0"/>
         </ser>
-        <gapWidth val="120"/>
-        <overlap val="100"/>
         <axId val="10"/>
         <axId val="100"/>
-      </barChart>
+      </lineChart>
       <catAx>
         <axId val="10"/>
         <scaling>
@@ -2869,7 +3019,7 @@
         <axId val="100"/>
         <scaling>
           <orientation val="minMax"/>
-          <max val="45000"/>
+          <max val="25000"/>
           <min val="0"/>
         </scaling>
         <delete val="0"/>
@@ -2884,7 +3034,7 @@
             </a:ln>
           </spPr>
         </majorGridlines>
-        <numFmt formatCode="[=0]0;#,##0,&quot;K&quot;" sourceLinked="0"/>
+        <numFmt formatCode="#,##0" sourceLinked="0"/>
         <majorTickMark val="none"/>
         <minorTickMark val="none"/>
         <tickLblPos val="nextTo"/>
@@ -2917,11 +3067,15 @@
           </a:p>
         </txPr>
         <crossAx val="10"/>
-        <majorUnit val="10000"/>
+        <majorUnit val="5000"/>
       </valAx>
     </plotArea>
     <legend>
       <legendPos val="b"/>
+      <legendEntry>
+        <idx val="5"/>
+        <delete val="1"/>
+      </legendEntry>
       <overlay val="0"/>
       <txPr>
         <a:bodyPr/>
@@ -3033,7 +3187,7 @@
             <numRef>
               <f>'Chart Data'!$B$17:$F$17</f>
               <numCache>
-                <formatCode>General</formatCode>
+                <formatCode>#,##0</formatCode>
                 <ptCount val="5"/>
                 <pt idx="0">
                   <v>2970</v>
@@ -3106,7 +3260,7 @@
             <numRef>
               <f>'Chart Data'!$B$18:$F$18</f>
               <numCache>
-                <formatCode>General</formatCode>
+                <formatCode>#,##0</formatCode>
                 <ptCount val="5"/>
                 <pt idx="0">
                   <v>1800</v>
@@ -3179,7 +3333,7 @@
             <numRef>
               <f>'Chart Data'!$B$19:$F$19</f>
               <numCache>
-                <formatCode>General</formatCode>
+                <formatCode>#,##0</formatCode>
                 <ptCount val="5"/>
                 <pt idx="0">
                   <v>735</v>
@@ -3252,7 +3406,7 @@
             <numRef>
               <f>'Chart Data'!$B$20:$F$20</f>
               <numCache>
-                <formatCode>General</formatCode>
+                <formatCode>#,##0</formatCode>
                 <ptCount val="5"/>
                 <pt idx="0">
                   <v>1800</v>
@@ -3305,7 +3459,29 @@
           <dLbls>
             <dLbl>
               <idx val="4"/>
-              <numFmt formatCode="#,##0"/>
+              <numFmt formatCode="#,##0" sourceLinked="0"/>
+              <txPr>
+                <a:bodyPr/>
+                <a:p>
+                  <a:pPr>
+                    <a:defRPr sz="1150" b="1" i="0">
+                      <a:solidFill>
+                        <a:srgbClr val="595959"/>
+                      </a:solidFill>
+                      <a:latin typeface="Aptos Narrow"/>
+                    </a:defRPr>
+                  </a:pPr>
+                  <a:r>
+                    <a:t/>
+                  </a:r>
+                  <a:endParaRPr sz="1150" b="1" i="0">
+                    <a:solidFill>
+                      <a:srgbClr val="595959"/>
+                    </a:solidFill>
+                    <a:latin typeface="Aptos Narrow"/>
+                  </a:endParaRPr>
+                </a:p>
+              </txPr>
               <dLblPos val="t"/>
               <showLegendKey val="0"/>
               <showVal val="1"/>
@@ -3314,7 +3490,7 @@
               <showPercent val="0"/>
               <showBubbleSize val="0"/>
             </dLbl>
-            <numFmt formatCode="#,##0"/>
+            <numFmt formatCode="#,##0" sourceLinked="0"/>
             <txPr>
               <a:bodyPr/>
               <a:p>
@@ -3348,22 +3524,22 @@
             <numRef>
               <f>'Chart Data'!$B$14:$F$14</f>
               <numCache>
-                <formatCode>General</formatCode>
+                <formatCode>#,##0</formatCode>
                 <ptCount val="5"/>
                 <pt idx="0">
-                  <v>21890.5406138028</v>
+                  <v>21891</v>
                 </pt>
                 <pt idx="1">
-                  <v>21890.5406138028</v>
+                  <v>21891</v>
                 </pt>
                 <pt idx="2">
-                  <v>21890.5406138028</v>
+                  <v>21891</v>
                 </pt>
                 <pt idx="3">
-                  <v>21890.5406138028</v>
+                  <v>21891</v>
                 </pt>
                 <pt idx="4">
-                  <v>21890.5406138028</v>
+                  <v>21891</v>
                 </pt>
               </numCache>
             </numRef>
@@ -3391,7 +3567,7 @@
             </spPr>
           </marker>
           <dLbls>
-            <numFmt formatCode="#,##0"/>
+            <numFmt formatCode="#,##0" sourceLinked="0"/>
             <txPr>
               <a:bodyPr/>
               <a:p>
@@ -3426,7 +3602,7 @@
             <numRef>
               <f>'Chart Data'!$B$21:$F$21</f>
               <numCache>
-                <formatCode>General</formatCode>
+                <formatCode>#,##0</formatCode>
                 <ptCount val="5"/>
                 <pt idx="0">
                   <v>7305</v>
@@ -3514,7 +3690,7 @@
             </a:ln>
           </spPr>
         </majorGridlines>
-        <numFmt formatCode="[=0]0;#,##0,&quot;K&quot;" sourceLinked="0"/>
+        <numFmt formatCode="#,##0" sourceLinked="0"/>
         <majorTickMark val="none"/>
         <minorTickMark val="none"/>
         <tickLblPos val="nextTo"/>
@@ -7016,7 +7192,7 @@
                 </a:solidFill>
                 <a:latin typeface="Aptos Narrow"/>
               </a:rPr>
-              <a:t>Net supply at spec yield vs demand</a:t>
+              <a:t>Capacity funnel: gross kill to net harvested</a:t>
             </a:r>
           </a:p>
         </p:txBody>
@@ -7051,7 +7227,7 @@
                 </a:solidFill>
                 <a:latin typeface="Aptos Narrow"/>
               </a:rPr>
-              <a:t>Spec-passed supply of 31,733 pigs per quarter covers peak demand about 3.8x — the gray band marks the 41,990 gross kill.</a:t>
+              <a:t>Each yield step shrinks supply: 41,990 gross, 31,733 after spec (-24%), 21,891 after harvest (-31%), against 8,434 peak demand.</a:t>
             </a:r>
           </a:p>
         </p:txBody>
@@ -7228,7 +7404,7 @@
                 </a:solidFill>
                 <a:latin typeface="Aptos Narrow"/>
               </a:rPr>
-              <a:t>Demand vs net harvested capacity (detail)</a:t>
+              <a:t>Net supply at spec yield vs demand</a:t>
             </a:r>
           </a:p>
         </p:txBody>
@@ -7263,7 +7439,7 @@
                 </a:solidFill>
                 <a:latin typeface="Aptos Narrow"/>
               </a:rPr>
-              <a:t>Demand rises 7,305 to 8,434 while net harvested capacity holds at 21,891 — a 2.6x cushion at peak.</a:t>
+              <a:t>Spec-passed supply of 31,733 pigs per quarter covers peak demand about 3.8x — the gray band marks the 41,990 gross kill.</a:t>
             </a:r>
           </a:p>
         </p:txBody>
@@ -7334,7 +7510,7 @@
                 </a:solidFill>
                 <a:latin typeface="Aptos Narrow"/>
               </a:rPr>
-              <a:t>Capacity funnel: gross kill to net harvested</a:t>
+              <a:t>Demand vs net harvested capacity (detail)</a:t>
             </a:r>
           </a:p>
         </p:txBody>
@@ -7369,7 +7545,7 @@
                 </a:solidFill>
                 <a:latin typeface="Aptos Narrow"/>
               </a:rPr>
-              <a:t>Each yield step shrinks supply: 41,990 gross, 31,733 after spec (-24%), 21,891 after harvest (-31%), against 8,434 peak demand.</a:t>
+              <a:t>Demand rises 7,305 to 8,434 while net harvested capacity holds at 21,891 — a 2.6x cushion at peak.</a:t>
             </a:r>
           </a:p>
         </p:txBody>

</xml_diff>